<commit_message>
Draw the equal-energy lines the 90.1 claim depends on
Slide 7 asserted that ASHRAE 90.1 "draws a direction" on the chart, but the
constant-enthalpy lines carrying that argument were never plotted. Add them to
both the slide 4 chart and the slide 7 motif, computed at dW/dT = -0.402 g/kg
per degC and clipped against the saturation curve, and annotate the worked
comparison: outside air at 79 kJ/kg against return air at 48, so no free
cooling.

Also qualify the 90.1 card - only the air-side of that standard lives on the
chart; fan power and chiller efficiency do not.

Co-authored-by: Cursor <cursoragent@cursor.com>
</commit_message>
<xml_diff>
--- a/Psychart-HVAC-ASHRAE-Overview.pptx
+++ b/Psychart-HVAC-ASHRAE-Overview.pptx
@@ -6569,9 +6569,156 @@
           </a:fontRef>
         </p:style>
       </p:cxnSp>
-      <p:sp>
-        <p:nvSpPr>
-          <p:cNvPr id="21" name="Freeform 20"/>
+      <p:cxnSp>
+        <p:nvCxnSpPr>
+          <p:cNvPr id="21" name="Connector 20"/>
+          <p:cNvCxnSpPr/>
+          <p:nvPr/>
+        </p:nvCxnSpPr>
+        <p:spPr>
+          <a:xfrm>
+            <a:off x="2172614" y="4206856"/>
+            <a:ext cx="2355494" cy="864569"/>
+          </a:xfrm>
+          <a:prstGeom prst="line">
+            <a:avLst/>
+          </a:prstGeom>
+          <a:ln w="11430">
+            <a:solidFill>
+              <a:srgbClr val="7C3AED"/>
+            </a:solidFill>
+            <a:prstDash val="dash"/>
+          </a:ln>
+        </p:spPr>
+        <p:style>
+          <a:lnRef idx="2">
+            <a:schemeClr val="accent1"/>
+          </a:lnRef>
+          <a:fillRef idx="0">
+            <a:schemeClr val="accent1"/>
+          </a:fillRef>
+          <a:effectRef idx="1">
+            <a:schemeClr val="accent1"/>
+          </a:effectRef>
+          <a:fontRef idx="minor">
+            <a:schemeClr val="tx1"/>
+          </a:fontRef>
+        </p:style>
+      </p:cxnSp>
+      <p:cxnSp>
+        <p:nvCxnSpPr>
+          <p:cNvPr id="22" name="Connector 21"/>
+          <p:cNvCxnSpPr/>
+          <p:nvPr/>
+        </p:nvCxnSpPr>
+        <p:spPr>
+          <a:xfrm>
+            <a:off x="3571189" y="3064947"/>
+            <a:ext cx="1503731" cy="551934"/>
+          </a:xfrm>
+          <a:prstGeom prst="line">
+            <a:avLst/>
+          </a:prstGeom>
+          <a:ln w="11430">
+            <a:solidFill>
+              <a:srgbClr val="7C3AED"/>
+            </a:solidFill>
+            <a:prstDash val="dash"/>
+          </a:ln>
+        </p:spPr>
+        <p:style>
+          <a:lnRef idx="2">
+            <a:schemeClr val="accent1"/>
+          </a:lnRef>
+          <a:fillRef idx="0">
+            <a:schemeClr val="accent1"/>
+          </a:fillRef>
+          <a:effectRef idx="1">
+            <a:schemeClr val="accent1"/>
+          </a:effectRef>
+          <a:fontRef idx="minor">
+            <a:schemeClr val="tx1"/>
+          </a:fontRef>
+        </p:style>
+      </p:cxnSp>
+      <p:cxnSp>
+        <p:nvCxnSpPr>
+          <p:cNvPr id="23" name="Connector 22"/>
+          <p:cNvCxnSpPr/>
+          <p:nvPr/>
+        </p:nvCxnSpPr>
+        <p:spPr>
+          <a:xfrm>
+            <a:off x="2645816" y="3907970"/>
+            <a:ext cx="2429104" cy="891587"/>
+          </a:xfrm>
+          <a:prstGeom prst="line">
+            <a:avLst/>
+          </a:prstGeom>
+          <a:ln w="17780">
+            <a:solidFill>
+              <a:srgbClr val="7C3AED"/>
+            </a:solidFill>
+            <a:prstDash val="dash"/>
+          </a:ln>
+        </p:spPr>
+        <p:style>
+          <a:lnRef idx="2">
+            <a:schemeClr val="accent1"/>
+          </a:lnRef>
+          <a:fillRef idx="0">
+            <a:schemeClr val="accent1"/>
+          </a:fillRef>
+          <a:effectRef idx="1">
+            <a:schemeClr val="accent1"/>
+          </a:effectRef>
+          <a:fontRef idx="minor">
+            <a:schemeClr val="tx1"/>
+          </a:fontRef>
+        </p:style>
+      </p:cxnSp>
+      <p:sp>
+        <p:nvSpPr>
+          <p:cNvPr id="24" name="TextBox 23"/>
+          <p:cNvSpPr txBox="1"/>
+          <p:nvPr/>
+        </p:nvSpPr>
+        <p:spPr>
+          <a:xfrm>
+            <a:off x="1221638" y="3711275"/>
+            <a:ext cx="1371600" cy="228600"/>
+          </a:xfrm>
+          <a:prstGeom prst="rect">
+            <a:avLst/>
+          </a:prstGeom>
+          <a:noFill/>
+        </p:spPr>
+        <p:txBody>
+          <a:bodyPr wrap="square" anchor="t" lIns="25400" rIns="25400" tIns="25400" bIns="25400">
+            <a:spAutoFit/>
+          </a:bodyPr>
+          <a:lstStyle/>
+          <a:p>
+            <a:pPr algn="r">
+              <a:lnSpc>
+                <a:spcPct val="106000"/>
+              </a:lnSpc>
+            </a:pPr>
+            <a:r>
+              <a:rPr sz="900" b="1">
+                <a:solidFill>
+                  <a:srgbClr val="7C3AED"/>
+                </a:solidFill>
+                <a:latin typeface="Calibri"/>
+              </a:rPr>
+              <a:t>equal energy (enthalpy)</a:t>
+            </a:r>
+          </a:p>
+        </p:txBody>
+      </p:sp>
+      <p:sp>
+        <p:nvSpPr>
+          <p:cNvPr id="25" name="Freeform 24"/>
           <p:cNvSpPr/>
           <p:nvPr/>
         </p:nvSpPr>
@@ -6647,7 +6794,7 @@
       </p:sp>
       <p:sp>
         <p:nvSpPr>
-          <p:cNvPr id="22" name="TextBox 21"/>
+          <p:cNvPr id="26" name="TextBox 25"/>
           <p:cNvSpPr txBox="1"/>
           <p:nvPr/>
         </p:nvSpPr>
@@ -6702,7 +6849,7 @@
       </p:sp>
       <p:sp>
         <p:nvSpPr>
-          <p:cNvPr id="23" name="Rounded Rectangle 22"/>
+          <p:cNvPr id="27" name="Rounded Rectangle 26"/>
           <p:cNvSpPr/>
           <p:nvPr/>
         </p:nvSpPr>
@@ -6750,7 +6897,7 @@
       </p:sp>
       <p:sp>
         <p:nvSpPr>
-          <p:cNvPr id="24" name="TextBox 23"/>
+          <p:cNvPr id="28" name="TextBox 27"/>
           <p:cNvSpPr txBox="1"/>
           <p:nvPr/>
         </p:nvSpPr>
@@ -6789,7 +6936,7 @@
       </p:sp>
       <p:cxnSp>
         <p:nvCxnSpPr>
-          <p:cNvPr id="25" name="Connector 24"/>
+          <p:cNvPr id="29" name="Connector 28"/>
           <p:cNvCxnSpPr/>
           <p:nvPr/>
         </p:nvCxnSpPr>
@@ -6825,7 +6972,7 @@
       </p:cxnSp>
       <p:cxnSp>
         <p:nvCxnSpPr>
-          <p:cNvPr id="26" name="Connector 25"/>
+          <p:cNvPr id="30" name="Connector 29"/>
           <p:cNvCxnSpPr/>
           <p:nvPr/>
         </p:nvCxnSpPr>
@@ -6860,7 +7007,7 @@
       </p:cxnSp>
       <p:sp>
         <p:nvSpPr>
-          <p:cNvPr id="27" name="Oval 26"/>
+          <p:cNvPr id="31" name="Oval 30"/>
           <p:cNvSpPr/>
           <p:nvPr/>
         </p:nvSpPr>
@@ -6906,7 +7053,7 @@
       </p:sp>
       <p:sp>
         <p:nvSpPr>
-          <p:cNvPr id="28" name="TextBox 27"/>
+          <p:cNvPr id="32" name="TextBox 31"/>
           <p:cNvSpPr txBox="1"/>
           <p:nvPr/>
         </p:nvSpPr>
@@ -6945,7 +7092,7 @@
       </p:sp>
       <p:sp>
         <p:nvSpPr>
-          <p:cNvPr id="29" name="Oval 28"/>
+          <p:cNvPr id="33" name="Oval 32"/>
           <p:cNvSpPr/>
           <p:nvPr/>
         </p:nvSpPr>
@@ -6991,7 +7138,7 @@
       </p:sp>
       <p:sp>
         <p:nvSpPr>
-          <p:cNvPr id="30" name="TextBox 29"/>
+          <p:cNvPr id="34" name="TextBox 33"/>
           <p:cNvSpPr txBox="1"/>
           <p:nvPr/>
         </p:nvSpPr>
@@ -7030,7 +7177,7 @@
       </p:sp>
       <p:sp>
         <p:nvSpPr>
-          <p:cNvPr id="31" name="Oval 30"/>
+          <p:cNvPr id="35" name="Oval 34"/>
           <p:cNvSpPr/>
           <p:nvPr/>
         </p:nvSpPr>
@@ -7076,7 +7223,7 @@
       </p:sp>
       <p:sp>
         <p:nvSpPr>
-          <p:cNvPr id="32" name="TextBox 31"/>
+          <p:cNvPr id="36" name="TextBox 35"/>
           <p:cNvSpPr txBox="1"/>
           <p:nvPr/>
         </p:nvSpPr>
@@ -7115,7 +7262,7 @@
       </p:sp>
       <p:sp>
         <p:nvSpPr>
-          <p:cNvPr id="33" name="Oval 32"/>
+          <p:cNvPr id="37" name="Oval 36"/>
           <p:cNvSpPr/>
           <p:nvPr/>
         </p:nvSpPr>
@@ -7161,7 +7308,7 @@
       </p:sp>
       <p:sp>
         <p:nvSpPr>
-          <p:cNvPr id="34" name="TextBox 33"/>
+          <p:cNvPr id="38" name="TextBox 37"/>
           <p:cNvSpPr txBox="1"/>
           <p:nvPr/>
         </p:nvSpPr>
@@ -7200,7 +7347,7 @@
       </p:sp>
       <p:sp>
         <p:nvSpPr>
-          <p:cNvPr id="35" name="TextBox 34"/>
+          <p:cNvPr id="39" name="TextBox 38"/>
           <p:cNvSpPr txBox="1"/>
           <p:nvPr/>
         </p:nvSpPr>
@@ -7239,7 +7386,7 @@
       </p:sp>
       <p:sp>
         <p:nvSpPr>
-          <p:cNvPr id="36" name="TextBox 35"/>
+          <p:cNvPr id="40" name="TextBox 39"/>
           <p:cNvSpPr txBox="1"/>
           <p:nvPr/>
         </p:nvSpPr>
@@ -7278,14 +7425,14 @@
       </p:sp>
       <p:sp>
         <p:nvSpPr>
-          <p:cNvPr id="37" name="TextBox 36"/>
+          <p:cNvPr id="41" name="TextBox 40"/>
           <p:cNvSpPr txBox="1"/>
           <p:nvPr/>
         </p:nvSpPr>
         <p:spPr>
           <a:xfrm>
             <a:off x="566928" y="5504688"/>
-            <a:ext cx="5120640" cy="731520"/>
+            <a:ext cx="5120640" cy="960120"/>
           </a:xfrm>
           <a:prstGeom prst="rect">
             <a:avLst/>
@@ -7300,40 +7447,24 @@
           <a:p>
             <a:pPr algn="l">
               <a:lnSpc>
-                <a:spcPct val="125000"/>
-              </a:lnSpc>
-            </a:pPr>
-            <a:r>
-              <a:rPr sz="1100" b="0">
+                <a:spcPct val="120000"/>
+              </a:lnSpc>
+            </a:pPr>
+            <a:r>
+              <a:rPr sz="1050" b="0">
                 <a:solidFill>
                   <a:srgbClr val="64748B"/>
                 </a:solidFill>
                 <a:latin typeface="Calibri"/>
               </a:rPr>
-              <a:t>OA outside air  ·  RA return air from the rooms  ·  MA the mixture entering the coil  ·  SA supply air delivered to the rooms.</a:t>
-            </a:r>
-          </a:p>
-          <a:p>
-            <a:pPr algn="l">
-              <a:lnSpc>
-                <a:spcPct val="125000"/>
-              </a:lnSpc>
-            </a:pPr>
-            <a:r>
-              <a:rPr sz="1100" b="0">
-                <a:solidFill>
-                  <a:srgbClr val="64748B"/>
-                </a:solidFill>
-                <a:latin typeface="Calibri"/>
-              </a:rPr>
-              <a:t>Dashed green = mixing;  solid blue = the cooling coil.</a:t>
-            </a:r>
-          </a:p>
-        </p:txBody>
-      </p:sp>
-      <p:sp>
-        <p:nvSpPr>
-          <p:cNvPr id="38" name="Rounded Rectangle 37"/>
+              <a:t>OA outside air  ·  RA return air  ·  MA the mixture entering the coil  ·  SA supply air delivered to the rooms. Dashed green = mixing; solid blue = the cooling coil. The violet diagonals are lines of equal total energy: outside air here holds 79 kJ/kg against return air's 48, so it sits well above RA's line and costs more to condition — no free cooling today.</a:t>
+            </a:r>
+          </a:p>
+        </p:txBody>
+      </p:sp>
+      <p:sp>
+        <p:nvSpPr>
+          <p:cNvPr id="42" name="Rounded Rectangle 41"/>
           <p:cNvSpPr/>
           <p:nvPr/>
         </p:nvSpPr>
@@ -7379,7 +7510,7 @@
       </p:sp>
       <p:sp>
         <p:nvSpPr>
-          <p:cNvPr id="39" name="Oval 38"/>
+          <p:cNvPr id="43" name="Oval 42"/>
           <p:cNvSpPr/>
           <p:nvPr/>
         </p:nvSpPr>
@@ -7423,7 +7554,7 @@
       </p:sp>
       <p:sp>
         <p:nvSpPr>
-          <p:cNvPr id="40" name="TextBox 39"/>
+          <p:cNvPr id="44" name="TextBox 43"/>
           <p:cNvSpPr txBox="1"/>
           <p:nvPr/>
         </p:nvSpPr>
@@ -7462,7 +7593,7 @@
       </p:sp>
       <p:sp>
         <p:nvSpPr>
-          <p:cNvPr id="41" name="TextBox 40"/>
+          <p:cNvPr id="45" name="TextBox 44"/>
           <p:cNvSpPr txBox="1"/>
           <p:nvPr/>
         </p:nvSpPr>
@@ -7501,7 +7632,7 @@
       </p:sp>
       <p:sp>
         <p:nvSpPr>
-          <p:cNvPr id="42" name="TextBox 41"/>
+          <p:cNvPr id="46" name="TextBox 45"/>
           <p:cNvSpPr txBox="1"/>
           <p:nvPr/>
         </p:nvSpPr>
@@ -7540,7 +7671,7 @@
       </p:sp>
       <p:sp>
         <p:nvSpPr>
-          <p:cNvPr id="43" name="Rounded Rectangle 42"/>
+          <p:cNvPr id="47" name="Rounded Rectangle 46"/>
           <p:cNvSpPr/>
           <p:nvPr/>
         </p:nvSpPr>
@@ -7586,7 +7717,7 @@
       </p:sp>
       <p:sp>
         <p:nvSpPr>
-          <p:cNvPr id="44" name="Oval 43"/>
+          <p:cNvPr id="48" name="Oval 47"/>
           <p:cNvSpPr/>
           <p:nvPr/>
         </p:nvSpPr>
@@ -7630,7 +7761,7 @@
       </p:sp>
       <p:sp>
         <p:nvSpPr>
-          <p:cNvPr id="45" name="TextBox 44"/>
+          <p:cNvPr id="49" name="TextBox 48"/>
           <p:cNvSpPr txBox="1"/>
           <p:nvPr/>
         </p:nvSpPr>
@@ -7669,7 +7800,7 @@
       </p:sp>
       <p:sp>
         <p:nvSpPr>
-          <p:cNvPr id="46" name="TextBox 45"/>
+          <p:cNvPr id="50" name="TextBox 49"/>
           <p:cNvSpPr txBox="1"/>
           <p:nvPr/>
         </p:nvSpPr>
@@ -7708,7 +7839,7 @@
       </p:sp>
       <p:sp>
         <p:nvSpPr>
-          <p:cNvPr id="47" name="TextBox 46"/>
+          <p:cNvPr id="51" name="TextBox 50"/>
           <p:cNvSpPr txBox="1"/>
           <p:nvPr/>
         </p:nvSpPr>
@@ -7747,7 +7878,7 @@
       </p:sp>
       <p:sp>
         <p:nvSpPr>
-          <p:cNvPr id="48" name="Rounded Rectangle 47"/>
+          <p:cNvPr id="52" name="Rounded Rectangle 51"/>
           <p:cNvSpPr/>
           <p:nvPr/>
         </p:nvSpPr>
@@ -7793,7 +7924,7 @@
       </p:sp>
       <p:sp>
         <p:nvSpPr>
-          <p:cNvPr id="49" name="Oval 48"/>
+          <p:cNvPr id="53" name="Oval 52"/>
           <p:cNvSpPr/>
           <p:nvPr/>
         </p:nvSpPr>
@@ -7837,7 +7968,7 @@
       </p:sp>
       <p:sp>
         <p:nvSpPr>
-          <p:cNvPr id="50" name="TextBox 49"/>
+          <p:cNvPr id="54" name="TextBox 53"/>
           <p:cNvSpPr txBox="1"/>
           <p:nvPr/>
         </p:nvSpPr>
@@ -7876,7 +8007,7 @@
       </p:sp>
       <p:sp>
         <p:nvSpPr>
-          <p:cNvPr id="51" name="TextBox 50"/>
+          <p:cNvPr id="55" name="TextBox 54"/>
           <p:cNvSpPr txBox="1"/>
           <p:nvPr/>
         </p:nvSpPr>
@@ -7915,7 +8046,7 @@
       </p:sp>
       <p:sp>
         <p:nvSpPr>
-          <p:cNvPr id="52" name="TextBox 51"/>
+          <p:cNvPr id="56" name="TextBox 55"/>
           <p:cNvSpPr txBox="1"/>
           <p:nvPr/>
         </p:nvSpPr>
@@ -7954,7 +8085,7 @@
       </p:sp>
       <p:sp>
         <p:nvSpPr>
-          <p:cNvPr id="53" name="Rounded Rectangle 52"/>
+          <p:cNvPr id="57" name="Rounded Rectangle 56"/>
           <p:cNvSpPr/>
           <p:nvPr/>
         </p:nvSpPr>
@@ -8000,7 +8131,7 @@
       </p:sp>
       <p:sp>
         <p:nvSpPr>
-          <p:cNvPr id="54" name="Oval 53"/>
+          <p:cNvPr id="58" name="Oval 57"/>
           <p:cNvSpPr/>
           <p:nvPr/>
         </p:nvSpPr>
@@ -8044,7 +8175,7 @@
       </p:sp>
       <p:sp>
         <p:nvSpPr>
-          <p:cNvPr id="55" name="TextBox 54"/>
+          <p:cNvPr id="59" name="TextBox 58"/>
           <p:cNvSpPr txBox="1"/>
           <p:nvPr/>
         </p:nvSpPr>
@@ -8083,7 +8214,7 @@
       </p:sp>
       <p:sp>
         <p:nvSpPr>
-          <p:cNvPr id="56" name="TextBox 55"/>
+          <p:cNvPr id="60" name="TextBox 59"/>
           <p:cNvSpPr txBox="1"/>
           <p:nvPr/>
         </p:nvSpPr>
@@ -8122,7 +8253,7 @@
       </p:sp>
       <p:sp>
         <p:nvSpPr>
-          <p:cNvPr id="57" name="TextBox 56"/>
+          <p:cNvPr id="61" name="TextBox 60"/>
           <p:cNvSpPr txBox="1"/>
           <p:nvPr/>
         </p:nvSpPr>
@@ -8161,7 +8292,7 @@
       </p:sp>
       <p:sp>
         <p:nvSpPr>
-          <p:cNvPr id="58" name="Rounded Rectangle 57"/>
+          <p:cNvPr id="62" name="Rounded Rectangle 61"/>
           <p:cNvSpPr/>
           <p:nvPr/>
         </p:nvSpPr>
@@ -8207,7 +8338,7 @@
       </p:sp>
       <p:sp>
         <p:nvSpPr>
-          <p:cNvPr id="59" name="Oval 58"/>
+          <p:cNvPr id="63" name="Oval 62"/>
           <p:cNvSpPr/>
           <p:nvPr/>
         </p:nvSpPr>
@@ -8251,7 +8382,7 @@
       </p:sp>
       <p:sp>
         <p:nvSpPr>
-          <p:cNvPr id="60" name="TextBox 59"/>
+          <p:cNvPr id="64" name="TextBox 63"/>
           <p:cNvSpPr txBox="1"/>
           <p:nvPr/>
         </p:nvSpPr>
@@ -8290,7 +8421,7 @@
       </p:sp>
       <p:sp>
         <p:nvSpPr>
-          <p:cNvPr id="61" name="TextBox 60"/>
+          <p:cNvPr id="65" name="TextBox 64"/>
           <p:cNvSpPr txBox="1"/>
           <p:nvPr/>
         </p:nvSpPr>
@@ -8329,7 +8460,7 @@
       </p:sp>
       <p:sp>
         <p:nvSpPr>
-          <p:cNvPr id="62" name="TextBox 61"/>
+          <p:cNvPr id="66" name="TextBox 65"/>
           <p:cNvSpPr txBox="1"/>
           <p:nvPr/>
         </p:nvSpPr>
@@ -8368,7 +8499,7 @@
       </p:sp>
       <p:sp>
         <p:nvSpPr>
-          <p:cNvPr id="63" name="Rounded Rectangle 62"/>
+          <p:cNvPr id="67" name="Rounded Rectangle 66"/>
           <p:cNvSpPr/>
           <p:nvPr/>
         </p:nvSpPr>
@@ -8414,7 +8545,7 @@
       </p:sp>
       <p:sp>
         <p:nvSpPr>
-          <p:cNvPr id="64" name="Oval 63"/>
+          <p:cNvPr id="68" name="Oval 67"/>
           <p:cNvSpPr/>
           <p:nvPr/>
         </p:nvSpPr>
@@ -8458,7 +8589,7 @@
       </p:sp>
       <p:sp>
         <p:nvSpPr>
-          <p:cNvPr id="65" name="TextBox 64"/>
+          <p:cNvPr id="69" name="TextBox 68"/>
           <p:cNvSpPr txBox="1"/>
           <p:nvPr/>
         </p:nvSpPr>
@@ -8497,7 +8628,7 @@
       </p:sp>
       <p:sp>
         <p:nvSpPr>
-          <p:cNvPr id="66" name="TextBox 65"/>
+          <p:cNvPr id="70" name="TextBox 69"/>
           <p:cNvSpPr txBox="1"/>
           <p:nvPr/>
         </p:nvSpPr>
@@ -8536,7 +8667,7 @@
       </p:sp>
       <p:sp>
         <p:nvSpPr>
-          <p:cNvPr id="67" name="TextBox 66"/>
+          <p:cNvPr id="71" name="TextBox 70"/>
           <p:cNvSpPr txBox="1"/>
           <p:nvPr/>
         </p:nvSpPr>
@@ -11178,8 +11309,8 @@
         </p:nvSpPr>
         <p:spPr>
           <a:xfrm>
-            <a:off x="4343400" y="1965960"/>
-            <a:ext cx="3520440" cy="3566160"/>
+            <a:off x="4343400" y="1920240"/>
+            <a:ext cx="3520440" cy="3657600"/>
           </a:xfrm>
           <a:prstGeom prst="roundRect">
             <a:avLst/>
@@ -11364,9 +11495,117 @@
           </a:fontRef>
         </p:style>
       </p:cxnSp>
-      <p:sp>
-        <p:nvSpPr>
-          <p:cNvPr id="11" name="Freeform 10"/>
+      <p:cxnSp>
+        <p:nvCxnSpPr>
+          <p:cNvPr id="11" name="Connector 10"/>
+          <p:cNvCxnSpPr/>
+          <p:nvPr/>
+        </p:nvCxnSpPr>
+        <p:spPr>
+          <a:xfrm>
+            <a:off x="5525536" y="4183938"/>
+            <a:ext cx="1474744" cy="477571"/>
+          </a:xfrm>
+          <a:prstGeom prst="line">
+            <a:avLst/>
+          </a:prstGeom>
+          <a:ln w="11430">
+            <a:solidFill>
+              <a:srgbClr val="7C3AED"/>
+            </a:solidFill>
+            <a:prstDash val="dash"/>
+          </a:ln>
+        </p:spPr>
+        <p:style>
+          <a:lnRef idx="2">
+            <a:schemeClr val="accent1"/>
+          </a:lnRef>
+          <a:fillRef idx="0">
+            <a:schemeClr val="accent1"/>
+          </a:fillRef>
+          <a:effectRef idx="1">
+            <a:schemeClr val="accent1"/>
+          </a:effectRef>
+          <a:fontRef idx="minor">
+            <a:schemeClr val="tx1"/>
+          </a:fontRef>
+        </p:style>
+      </p:cxnSp>
+      <p:cxnSp>
+        <p:nvCxnSpPr>
+          <p:cNvPr id="12" name="Connector 11"/>
+          <p:cNvCxnSpPr/>
+          <p:nvPr/>
+        </p:nvCxnSpPr>
+        <p:spPr>
+          <a:xfrm>
+            <a:off x="6401165" y="3553169"/>
+            <a:ext cx="941467" cy="304878"/>
+          </a:xfrm>
+          <a:prstGeom prst="line">
+            <a:avLst/>
+          </a:prstGeom>
+          <a:ln w="11430">
+            <a:solidFill>
+              <a:srgbClr val="7C3AED"/>
+            </a:solidFill>
+            <a:prstDash val="dash"/>
+          </a:ln>
+        </p:spPr>
+        <p:style>
+          <a:lnRef idx="2">
+            <a:schemeClr val="accent1"/>
+          </a:lnRef>
+          <a:fillRef idx="0">
+            <a:schemeClr val="accent1"/>
+          </a:fillRef>
+          <a:effectRef idx="1">
+            <a:schemeClr val="accent1"/>
+          </a:effectRef>
+          <a:fontRef idx="minor">
+            <a:schemeClr val="tx1"/>
+          </a:fontRef>
+        </p:style>
+      </p:cxnSp>
+      <p:cxnSp>
+        <p:nvCxnSpPr>
+          <p:cNvPr id="13" name="Connector 12"/>
+          <p:cNvCxnSpPr/>
+          <p:nvPr/>
+        </p:nvCxnSpPr>
+        <p:spPr>
+          <a:xfrm>
+            <a:off x="5821801" y="4018839"/>
+            <a:ext cx="1520831" cy="492496"/>
+          </a:xfrm>
+          <a:prstGeom prst="line">
+            <a:avLst/>
+          </a:prstGeom>
+          <a:ln w="16510">
+            <a:solidFill>
+              <a:srgbClr val="7C3AED"/>
+            </a:solidFill>
+            <a:prstDash val="dash"/>
+          </a:ln>
+        </p:spPr>
+        <p:style>
+          <a:lnRef idx="2">
+            <a:schemeClr val="accent1"/>
+          </a:lnRef>
+          <a:fillRef idx="0">
+            <a:schemeClr val="accent1"/>
+          </a:fillRef>
+          <a:effectRef idx="1">
+            <a:schemeClr val="accent1"/>
+          </a:effectRef>
+          <a:fontRef idx="minor">
+            <a:schemeClr val="tx1"/>
+          </a:fontRef>
+        </p:style>
+      </p:cxnSp>
+      <p:sp>
+        <p:nvSpPr>
+          <p:cNvPr id="14" name="Freeform 13"/>
           <p:cNvSpPr/>
           <p:nvPr/>
         </p:nvSpPr>
@@ -11442,7 +11681,7 @@
       </p:sp>
       <p:sp>
         <p:nvSpPr>
-          <p:cNvPr id="12" name="Rounded Rectangle 11"/>
+          <p:cNvPr id="15" name="Rounded Rectangle 14"/>
           <p:cNvSpPr/>
           <p:nvPr/>
         </p:nvSpPr>
@@ -11490,7 +11729,7 @@
       </p:sp>
       <p:cxnSp>
         <p:nvCxnSpPr>
-          <p:cNvPr id="13" name="Connector 12"/>
+          <p:cNvPr id="16" name="Connector 15"/>
           <p:cNvCxnSpPr/>
           <p:nvPr/>
         </p:nvCxnSpPr>
@@ -11526,7 +11765,7 @@
       </p:cxnSp>
       <p:cxnSp>
         <p:nvCxnSpPr>
-          <p:cNvPr id="14" name="Connector 13"/>
+          <p:cNvPr id="17" name="Connector 16"/>
           <p:cNvCxnSpPr/>
           <p:nvPr/>
         </p:nvCxnSpPr>
@@ -11561,7 +11800,7 @@
       </p:cxnSp>
       <p:sp>
         <p:nvSpPr>
-          <p:cNvPr id="15" name="Oval 14"/>
+          <p:cNvPr id="18" name="Oval 17"/>
           <p:cNvSpPr/>
           <p:nvPr/>
         </p:nvSpPr>
@@ -11607,7 +11846,7 @@
       </p:sp>
       <p:sp>
         <p:nvSpPr>
-          <p:cNvPr id="16" name="Oval 15"/>
+          <p:cNvPr id="19" name="Oval 18"/>
           <p:cNvSpPr/>
           <p:nvPr/>
         </p:nvSpPr>
@@ -11653,7 +11892,7 @@
       </p:sp>
       <p:sp>
         <p:nvSpPr>
-          <p:cNvPr id="17" name="Oval 16"/>
+          <p:cNvPr id="20" name="Oval 19"/>
           <p:cNvSpPr/>
           <p:nvPr/>
         </p:nvSpPr>
@@ -11699,7 +11938,7 @@
       </p:sp>
       <p:sp>
         <p:nvSpPr>
-          <p:cNvPr id="18" name="Oval 17"/>
+          <p:cNvPr id="21" name="Oval 20"/>
           <p:cNvSpPr/>
           <p:nvPr/>
         </p:nvSpPr>
@@ -11745,7 +11984,7 @@
       </p:sp>
       <p:sp>
         <p:nvSpPr>
-          <p:cNvPr id="19" name="TextBox 18"/>
+          <p:cNvPr id="22" name="TextBox 21"/>
           <p:cNvSpPr txBox="1"/>
           <p:nvPr/>
         </p:nvSpPr>
@@ -11784,14 +12023,14 @@
       </p:sp>
       <p:sp>
         <p:nvSpPr>
-          <p:cNvPr id="20" name="Rounded Rectangle 19"/>
+          <p:cNvPr id="23" name="Rounded Rectangle 22"/>
           <p:cNvSpPr/>
           <p:nvPr/>
         </p:nvSpPr>
         <p:spPr>
           <a:xfrm>
-            <a:off x="640080" y="1965960"/>
-            <a:ext cx="3383280" cy="1554480"/>
+            <a:off x="640080" y="1920240"/>
+            <a:ext cx="3383280" cy="1737360"/>
           </a:xfrm>
           <a:prstGeom prst="roundRect">
             <a:avLst/>
@@ -11830,13 +12069,13 @@
       </p:sp>
       <p:sp>
         <p:nvSpPr>
-          <p:cNvPr id="21" name="Rectangle 20"/>
+          <p:cNvPr id="24" name="Rectangle 23"/>
           <p:cNvSpPr/>
           <p:nvPr/>
         </p:nvSpPr>
         <p:spPr>
           <a:xfrm>
-            <a:off x="640080" y="1965960"/>
+            <a:off x="640080" y="1920240"/>
             <a:ext cx="3383280" cy="91440"/>
           </a:xfrm>
           <a:prstGeom prst="rect">
@@ -11874,13 +12113,13 @@
       </p:sp>
       <p:sp>
         <p:nvSpPr>
-          <p:cNvPr id="22" name="TextBox 21"/>
+          <p:cNvPr id="25" name="TextBox 24"/>
           <p:cNvSpPr txBox="1"/>
           <p:nvPr/>
         </p:nvSpPr>
         <p:spPr>
           <a:xfrm>
-            <a:off x="877824" y="2167128"/>
+            <a:off x="877824" y="2121408"/>
             <a:ext cx="2926080" cy="292608"/>
           </a:xfrm>
           <a:prstGeom prst="rect">
@@ -11913,14 +12152,14 @@
       </p:sp>
       <p:sp>
         <p:nvSpPr>
-          <p:cNvPr id="23" name="TextBox 22"/>
+          <p:cNvPr id="26" name="TextBox 25"/>
           <p:cNvSpPr txBox="1"/>
           <p:nvPr/>
         </p:nvSpPr>
         <p:spPr>
           <a:xfrm>
-            <a:off x="877824" y="2532888"/>
-            <a:ext cx="2944368" cy="868680"/>
+            <a:off x="877824" y="2468880"/>
+            <a:ext cx="2944368" cy="777240"/>
           </a:xfrm>
           <a:prstGeom prst="rect">
             <a:avLst/>
@@ -11939,7 +12178,7 @@
               </a:lnSpc>
             </a:pPr>
             <a:r>
-              <a:rPr sz="1100" b="0">
+              <a:rPr sz="1050" b="0">
                 <a:solidFill>
                   <a:srgbClr val="475569"/>
                 </a:solidFill>
@@ -11952,14 +12191,14 @@
       </p:sp>
       <p:sp>
         <p:nvSpPr>
-          <p:cNvPr id="24" name="Rounded Rectangle 23"/>
+          <p:cNvPr id="27" name="Rounded Rectangle 26"/>
           <p:cNvSpPr/>
           <p:nvPr/>
         </p:nvSpPr>
         <p:spPr>
           <a:xfrm>
-            <a:off x="8165592" y="1965960"/>
-            <a:ext cx="3383280" cy="1554480"/>
+            <a:off x="8165592" y="1920240"/>
+            <a:ext cx="3383280" cy="1737360"/>
           </a:xfrm>
           <a:prstGeom prst="roundRect">
             <a:avLst/>
@@ -11998,13 +12237,13 @@
       </p:sp>
       <p:sp>
         <p:nvSpPr>
-          <p:cNvPr id="25" name="Rectangle 24"/>
+          <p:cNvPr id="28" name="Rectangle 27"/>
           <p:cNvSpPr/>
           <p:nvPr/>
         </p:nvSpPr>
         <p:spPr>
           <a:xfrm>
-            <a:off x="8165592" y="1965960"/>
+            <a:off x="8165592" y="1920240"/>
             <a:ext cx="3383280" cy="91440"/>
           </a:xfrm>
           <a:prstGeom prst="rect">
@@ -12042,13 +12281,13 @@
       </p:sp>
       <p:sp>
         <p:nvSpPr>
-          <p:cNvPr id="26" name="TextBox 25"/>
+          <p:cNvPr id="29" name="TextBox 28"/>
           <p:cNvSpPr txBox="1"/>
           <p:nvPr/>
         </p:nvSpPr>
         <p:spPr>
           <a:xfrm>
-            <a:off x="8403336" y="2167128"/>
+            <a:off x="8403336" y="2121408"/>
             <a:ext cx="2926080" cy="292608"/>
           </a:xfrm>
           <a:prstGeom prst="rect">
@@ -12081,14 +12320,14 @@
       </p:sp>
       <p:sp>
         <p:nvSpPr>
-          <p:cNvPr id="27" name="TextBox 26"/>
+          <p:cNvPr id="30" name="TextBox 29"/>
           <p:cNvSpPr txBox="1"/>
           <p:nvPr/>
         </p:nvSpPr>
         <p:spPr>
           <a:xfrm>
-            <a:off x="8403336" y="2532888"/>
-            <a:ext cx="2944368" cy="868680"/>
+            <a:off x="8403336" y="2468880"/>
+            <a:ext cx="2944368" cy="777240"/>
           </a:xfrm>
           <a:prstGeom prst="rect">
             <a:avLst/>
@@ -12107,7 +12346,7 @@
               </a:lnSpc>
             </a:pPr>
             <a:r>
-              <a:rPr sz="1100" b="0">
+              <a:rPr sz="1050" b="0">
                 <a:solidFill>
                   <a:srgbClr val="475569"/>
                 </a:solidFill>
@@ -12120,14 +12359,14 @@
       </p:sp>
       <p:sp>
         <p:nvSpPr>
-          <p:cNvPr id="28" name="Rounded Rectangle 27"/>
+          <p:cNvPr id="31" name="Rounded Rectangle 30"/>
           <p:cNvSpPr/>
           <p:nvPr/>
         </p:nvSpPr>
         <p:spPr>
           <a:xfrm>
-            <a:off x="640080" y="3977639"/>
-            <a:ext cx="3383280" cy="1554480"/>
+            <a:off x="640080" y="3840480"/>
+            <a:ext cx="3383280" cy="1737360"/>
           </a:xfrm>
           <a:prstGeom prst="roundRect">
             <a:avLst/>
@@ -12166,13 +12405,13 @@
       </p:sp>
       <p:sp>
         <p:nvSpPr>
-          <p:cNvPr id="29" name="Rectangle 28"/>
+          <p:cNvPr id="32" name="Rectangle 31"/>
           <p:cNvSpPr/>
           <p:nvPr/>
         </p:nvSpPr>
         <p:spPr>
           <a:xfrm>
-            <a:off x="640080" y="3977639"/>
+            <a:off x="640080" y="3840480"/>
             <a:ext cx="3383280" cy="91440"/>
           </a:xfrm>
           <a:prstGeom prst="rect">
@@ -12210,13 +12449,13 @@
       </p:sp>
       <p:sp>
         <p:nvSpPr>
-          <p:cNvPr id="30" name="TextBox 29"/>
+          <p:cNvPr id="33" name="TextBox 32"/>
           <p:cNvSpPr txBox="1"/>
           <p:nvPr/>
         </p:nvSpPr>
         <p:spPr>
           <a:xfrm>
-            <a:off x="877824" y="4178807"/>
+            <a:off x="877824" y="4041648"/>
             <a:ext cx="2926080" cy="292608"/>
           </a:xfrm>
           <a:prstGeom prst="rect">
@@ -12249,14 +12488,14 @@
       </p:sp>
       <p:sp>
         <p:nvSpPr>
-          <p:cNvPr id="31" name="TextBox 30"/>
+          <p:cNvPr id="34" name="TextBox 33"/>
           <p:cNvSpPr txBox="1"/>
           <p:nvPr/>
         </p:nvSpPr>
         <p:spPr>
           <a:xfrm>
-            <a:off x="877824" y="4544568"/>
-            <a:ext cx="2944368" cy="868680"/>
+            <a:off x="877824" y="4389120"/>
+            <a:ext cx="2944368" cy="777240"/>
           </a:xfrm>
           <a:prstGeom prst="rect">
             <a:avLst/>
@@ -12275,27 +12514,66 @@
               </a:lnSpc>
             </a:pPr>
             <a:r>
-              <a:rPr sz="1100" b="0">
+              <a:rPr sz="1050" b="0">
                 <a:solidFill>
                   <a:srgbClr val="475569"/>
                 </a:solidFill>
                 <a:latin typeface="Calibri"/>
               </a:rPr>
-              <a:t>Lines of equal energy content show when outside air is the cheaper source, and how far the dot may be pushed before energy is thrown away.</a:t>
-            </a:r>
-          </a:p>
-        </p:txBody>
-      </p:sp>
-      <p:sp>
-        <p:nvSpPr>
-          <p:cNvPr id="32" name="Rounded Rectangle 31"/>
+              <a:t>The violet diagonals are equal-energy lines. Which side of them outside air falls on decides whether it is the cheaper source — and how far the dot may be pushed before energy is wasted.</a:t>
+            </a:r>
+          </a:p>
+        </p:txBody>
+      </p:sp>
+      <p:sp>
+        <p:nvSpPr>
+          <p:cNvPr id="35" name="TextBox 34"/>
+          <p:cNvSpPr txBox="1"/>
+          <p:nvPr/>
+        </p:nvSpPr>
+        <p:spPr>
+          <a:xfrm>
+            <a:off x="877824" y="5193792"/>
+            <a:ext cx="2944368" cy="320040"/>
+          </a:xfrm>
+          <a:prstGeom prst="rect">
+            <a:avLst/>
+          </a:prstGeom>
+          <a:noFill/>
+        </p:spPr>
+        <p:txBody>
+          <a:bodyPr wrap="square" anchor="t" lIns="25400" rIns="25400" tIns="25400" bIns="25400">
+            <a:spAutoFit/>
+          </a:bodyPr>
+          <a:lstStyle/>
+          <a:p>
+            <a:pPr algn="l">
+              <a:lnSpc>
+                <a:spcPct val="110000"/>
+              </a:lnSpc>
+            </a:pPr>
+            <a:r>
+              <a:rPr sz="950" b="0">
+                <a:solidFill>
+                  <a:srgbClr val="64748B"/>
+                </a:solidFill>
+                <a:latin typeface="Calibri"/>
+              </a:rPr>
+              <a:t>Air-side only — fan power and chiller efficiency sit outside the chart.</a:t>
+            </a:r>
+          </a:p>
+        </p:txBody>
+      </p:sp>
+      <p:sp>
+        <p:nvSpPr>
+          <p:cNvPr id="36" name="Rounded Rectangle 35"/>
           <p:cNvSpPr/>
           <p:nvPr/>
         </p:nvSpPr>
         <p:spPr>
           <a:xfrm>
-            <a:off x="8165592" y="3977639"/>
-            <a:ext cx="3383280" cy="1554480"/>
+            <a:off x="8165592" y="3840480"/>
+            <a:ext cx="3383280" cy="1737360"/>
           </a:xfrm>
           <a:prstGeom prst="roundRect">
             <a:avLst/>
@@ -12334,13 +12612,13 @@
       </p:sp>
       <p:sp>
         <p:nvSpPr>
-          <p:cNvPr id="33" name="Rectangle 32"/>
+          <p:cNvPr id="37" name="Rectangle 36"/>
           <p:cNvSpPr/>
           <p:nvPr/>
         </p:nvSpPr>
         <p:spPr>
           <a:xfrm>
-            <a:off x="8165592" y="3977639"/>
+            <a:off x="8165592" y="3840480"/>
             <a:ext cx="3383280" cy="91440"/>
           </a:xfrm>
           <a:prstGeom prst="rect">
@@ -12378,13 +12656,13 @@
       </p:sp>
       <p:sp>
         <p:nvSpPr>
-          <p:cNvPr id="34" name="TextBox 33"/>
+          <p:cNvPr id="38" name="TextBox 37"/>
           <p:cNvSpPr txBox="1"/>
           <p:nvPr/>
         </p:nvSpPr>
         <p:spPr>
           <a:xfrm>
-            <a:off x="8403336" y="4178807"/>
+            <a:off x="8403336" y="4041648"/>
             <a:ext cx="2926080" cy="292608"/>
           </a:xfrm>
           <a:prstGeom prst="rect">
@@ -12417,14 +12695,14 @@
       </p:sp>
       <p:sp>
         <p:nvSpPr>
-          <p:cNvPr id="35" name="TextBox 34"/>
+          <p:cNvPr id="39" name="TextBox 38"/>
           <p:cNvSpPr txBox="1"/>
           <p:nvPr/>
         </p:nvSpPr>
         <p:spPr>
           <a:xfrm>
-            <a:off x="8403336" y="4544568"/>
-            <a:ext cx="2944368" cy="868680"/>
+            <a:off x="8403336" y="4389120"/>
+            <a:ext cx="2944368" cy="777240"/>
           </a:xfrm>
           <a:prstGeom prst="rect">
             <a:avLst/>
@@ -12443,7 +12721,7 @@
               </a:lnSpc>
             </a:pPr>
             <a:r>
-              <a:rPr sz="1100" b="0">
+              <a:rPr sz="1050" b="0">
                 <a:solidFill>
                   <a:srgbClr val="475569"/>
                 </a:solidFill>
@@ -12456,13 +12734,13 @@
       </p:sp>
       <p:sp>
         <p:nvSpPr>
-          <p:cNvPr id="36" name="Right Arrow 35"/>
+          <p:cNvPr id="40" name="Right Arrow 39"/>
           <p:cNvSpPr/>
           <p:nvPr/>
         </p:nvSpPr>
         <p:spPr>
           <a:xfrm>
-            <a:off x="4059936" y="2670048"/>
+            <a:off x="4059936" y="2715768"/>
             <a:ext cx="237744" cy="146304"/>
           </a:xfrm>
           <a:prstGeom prst="rightArrow">
@@ -12500,13 +12778,13 @@
       </p:sp>
       <p:sp>
         <p:nvSpPr>
-          <p:cNvPr id="37" name="Right Arrow 36"/>
+          <p:cNvPr id="41" name="Right Arrow 40"/>
           <p:cNvSpPr/>
           <p:nvPr/>
         </p:nvSpPr>
         <p:spPr>
           <a:xfrm>
-            <a:off x="4059936" y="4681728"/>
+            <a:off x="4059936" y="4636008"/>
             <a:ext cx="237744" cy="146304"/>
           </a:xfrm>
           <a:prstGeom prst="rightArrow">
@@ -12544,13 +12822,13 @@
       </p:sp>
       <p:sp>
         <p:nvSpPr>
-          <p:cNvPr id="38" name="Left Arrow 37"/>
+          <p:cNvPr id="42" name="Left Arrow 41"/>
           <p:cNvSpPr/>
           <p:nvPr/>
         </p:nvSpPr>
         <p:spPr>
           <a:xfrm>
-            <a:off x="7909560" y="2670048"/>
+            <a:off x="7909560" y="2715768"/>
             <a:ext cx="237744" cy="146304"/>
           </a:xfrm>
           <a:prstGeom prst="leftArrow">
@@ -12588,13 +12866,13 @@
       </p:sp>
       <p:sp>
         <p:nvSpPr>
-          <p:cNvPr id="39" name="Left Arrow 38"/>
+          <p:cNvPr id="43" name="Left Arrow 42"/>
           <p:cNvSpPr/>
           <p:nvPr/>
         </p:nvSpPr>
         <p:spPr>
           <a:xfrm>
-            <a:off x="7909560" y="4681728"/>
+            <a:off x="7909560" y="4636008"/>
             <a:ext cx="237744" cy="146304"/>
           </a:xfrm>
           <a:prstGeom prst="leftArrow">
@@ -12632,7 +12910,7 @@
       </p:sp>
       <p:sp>
         <p:nvSpPr>
-          <p:cNvPr id="40" name="Rounded Rectangle 39"/>
+          <p:cNvPr id="44" name="Rounded Rectangle 43"/>
           <p:cNvSpPr/>
           <p:nvPr/>
         </p:nvSpPr>
@@ -12678,7 +12956,7 @@
       </p:sp>
       <p:sp>
         <p:nvSpPr>
-          <p:cNvPr id="41" name="TextBox 40"/>
+          <p:cNvPr id="45" name="TextBox 44"/>
           <p:cNvSpPr txBox="1"/>
           <p:nvPr/>
         </p:nvSpPr>
@@ -12717,7 +12995,7 @@
       </p:sp>
       <p:sp>
         <p:nvSpPr>
-          <p:cNvPr id="42" name="TextBox 41"/>
+          <p:cNvPr id="46" name="TextBox 45"/>
           <p:cNvSpPr txBox="1"/>
           <p:nvPr/>
         </p:nvSpPr>

</xml_diff>

<commit_message>
Add savings slide with sourced figures and their caveats
Four published results rather than an in-house estimate: 31% average HVAC
saving from Guideline 36 sequences (Berkeley Lab, 2022), 9% median
whole-building saving from fault detection (Berkeley Lab Smart Energy
Analytics, 6,500 buildings), 64% of economizers found faulty in the field
(New Buildings Institute), and 20-41% seasonal savings from supervisory
resets (PNNL, 2024).

Each carries its source, and a caveat panel states that the figures overlap,
are climate- and baseline-dependent, and that Taylor & Cheng (2010) found
fixed dry-bulb can beat enthalpy switching once humidity-sensor drift is
counted. Deck is now 12 slides.

Co-authored-by: Cursor <cursoragent@cursor.com>
</commit_message>
<xml_diff>
--- a/Psychart-HVAC-ASHRAE-Overview.pptx
+++ b/Psychart-HVAC-ASHRAE-Overview.pptx
@@ -16,6 +16,7 @@
     <p:sldId id="264" r:id="rId15"/>
     <p:sldId id="265" r:id="rId16"/>
     <p:sldId id="266" r:id="rId17"/>
+    <p:sldId id="267" r:id="rId18"/>
   </p:sldIdLst>
   <p:sldSz cx="12191695" cy="6858000" type="screen4x3"/>
   <p:notesSz cx="6858000" cy="9144000"/>
@@ -4872,6 +4873,1401 @@
 </file>
 
 <file path=ppt/slides/slide11.xml><?xml version="1.0" encoding="utf-8"?>
+<p:sld xmlns:a="http://schemas.openxmlformats.org/drawingml/2006/main" xmlns:p="http://schemas.openxmlformats.org/presentationml/2006/main" xmlns:r="http://schemas.openxmlformats.org/officeDocument/2006/relationships">
+  <p:cSld>
+    <p:spTree>
+      <p:nvGrpSpPr>
+        <p:cNvPr id="1" name=""/>
+        <p:cNvGrpSpPr/>
+        <p:nvPr/>
+      </p:nvGrpSpPr>
+      <p:grpSpPr/>
+      <p:sp>
+        <p:nvSpPr>
+          <p:cNvPr id="2" name="Rectangle 1"/>
+          <p:cNvSpPr/>
+          <p:nvPr/>
+        </p:nvSpPr>
+        <p:spPr>
+          <a:xfrm>
+            <a:off x="0" y="0"/>
+            <a:ext cx="12191695" cy="6858000"/>
+          </a:xfrm>
+          <a:prstGeom prst="rect">
+            <a:avLst/>
+          </a:prstGeom>
+          <a:solidFill>
+            <a:srgbClr val="F8FAFC"/>
+          </a:solidFill>
+          <a:ln>
+            <a:noFill/>
+          </a:ln>
+          <a:effectLst/>
+        </p:spPr>
+        <p:style>
+          <a:lnRef idx="1">
+            <a:schemeClr val="accent1"/>
+          </a:lnRef>
+          <a:fillRef idx="3">
+            <a:schemeClr val="accent1"/>
+          </a:fillRef>
+          <a:effectRef idx="2">
+            <a:schemeClr val="accent1"/>
+          </a:effectRef>
+          <a:fontRef idx="minor">
+            <a:schemeClr val="lt1"/>
+          </a:fontRef>
+        </p:style>
+        <p:txBody>
+          <a:bodyPr rtlCol="0" anchor="ctr"/>
+          <a:lstStyle/>
+          <a:p>
+            <a:pPr algn="ctr"/>
+          </a:p>
+        </p:txBody>
+      </p:sp>
+      <p:sp>
+        <p:nvSpPr>
+          <p:cNvPr id="3" name="Rectangle 2"/>
+          <p:cNvSpPr/>
+          <p:nvPr/>
+        </p:nvSpPr>
+        <p:spPr>
+          <a:xfrm>
+            <a:off x="0" y="0"/>
+            <a:ext cx="12191695" cy="146304"/>
+          </a:xfrm>
+          <a:prstGeom prst="rect">
+            <a:avLst/>
+          </a:prstGeom>
+          <a:solidFill>
+            <a:srgbClr val="1D4ED8"/>
+          </a:solidFill>
+          <a:ln>
+            <a:noFill/>
+          </a:ln>
+          <a:effectLst/>
+        </p:spPr>
+        <p:style>
+          <a:lnRef idx="1">
+            <a:schemeClr val="accent1"/>
+          </a:lnRef>
+          <a:fillRef idx="3">
+            <a:schemeClr val="accent1"/>
+          </a:fillRef>
+          <a:effectRef idx="2">
+            <a:schemeClr val="accent1"/>
+          </a:effectRef>
+          <a:fontRef idx="minor">
+            <a:schemeClr val="lt1"/>
+          </a:fontRef>
+        </p:style>
+        <p:txBody>
+          <a:bodyPr rtlCol="0" anchor="ctr"/>
+          <a:lstStyle/>
+          <a:p>
+            <a:pPr algn="ctr"/>
+          </a:p>
+        </p:txBody>
+      </p:sp>
+      <p:sp>
+        <p:nvSpPr>
+          <p:cNvPr id="4" name="TextBox 3"/>
+          <p:cNvSpPr txBox="1"/>
+          <p:nvPr/>
+        </p:nvSpPr>
+        <p:spPr>
+          <a:xfrm>
+            <a:off x="640080" y="384048"/>
+            <a:ext cx="10881360" cy="365760"/>
+          </a:xfrm>
+          <a:prstGeom prst="rect">
+            <a:avLst/>
+          </a:prstGeom>
+          <a:noFill/>
+        </p:spPr>
+        <p:txBody>
+          <a:bodyPr wrap="square" anchor="t" lIns="25400" rIns="25400" tIns="25400" bIns="25400">
+            <a:spAutoFit/>
+          </a:bodyPr>
+          <a:lstStyle/>
+          <a:p>
+            <a:pPr algn="l">
+              <a:lnSpc>
+                <a:spcPct val="106000"/>
+              </a:lnSpc>
+            </a:pPr>
+            <a:r>
+              <a:rPr sz="1300" b="1">
+                <a:solidFill>
+                  <a:srgbClr val="1D4ED8"/>
+                </a:solidFill>
+                <a:latin typeface="Calibri"/>
+              </a:rPr>
+              <a:t>PUBLISHED EVIDENCE</a:t>
+            </a:r>
+          </a:p>
+        </p:txBody>
+      </p:sp>
+      <p:sp>
+        <p:nvSpPr>
+          <p:cNvPr id="5" name="TextBox 4"/>
+          <p:cNvSpPr txBox="1"/>
+          <p:nvPr/>
+        </p:nvSpPr>
+        <p:spPr>
+          <a:xfrm>
+            <a:off x="640080" y="713232"/>
+            <a:ext cx="10881360" cy="914400"/>
+          </a:xfrm>
+          <a:prstGeom prst="rect">
+            <a:avLst/>
+          </a:prstGeom>
+          <a:noFill/>
+        </p:spPr>
+        <p:txBody>
+          <a:bodyPr wrap="square" anchor="t" lIns="25400" rIns="25400" tIns="25400" bIns="25400">
+            <a:spAutoFit/>
+          </a:bodyPr>
+          <a:lstStyle/>
+          <a:p>
+            <a:pPr algn="l">
+              <a:lnSpc>
+                <a:spcPct val="106000"/>
+              </a:lnSpc>
+            </a:pPr>
+            <a:r>
+              <a:rPr sz="3000" b="1">
+                <a:solidFill>
+                  <a:srgbClr val="0F172A"/>
+                </a:solidFill>
+                <a:latin typeface="Calibri"/>
+              </a:rPr>
+              <a:t>What is it worth?</a:t>
+            </a:r>
+          </a:p>
+        </p:txBody>
+      </p:sp>
+      <p:sp>
+        <p:nvSpPr>
+          <p:cNvPr id="6" name="Rounded Rectangle 5"/>
+          <p:cNvSpPr/>
+          <p:nvPr/>
+        </p:nvSpPr>
+        <p:spPr>
+          <a:xfrm>
+            <a:off x="640080" y="1874519"/>
+            <a:ext cx="2587752" cy="1920240"/>
+          </a:xfrm>
+          <a:prstGeom prst="roundRect">
+            <a:avLst/>
+          </a:prstGeom>
+          <a:solidFill>
+            <a:srgbClr val="FFFFFF"/>
+          </a:solidFill>
+          <a:ln w="12700">
+            <a:solidFill>
+              <a:srgbClr val="E2E8F0"/>
+            </a:solidFill>
+          </a:ln>
+          <a:effectLst/>
+        </p:spPr>
+        <p:style>
+          <a:lnRef idx="1">
+            <a:schemeClr val="accent1"/>
+          </a:lnRef>
+          <a:fillRef idx="3">
+            <a:schemeClr val="accent1"/>
+          </a:fillRef>
+          <a:effectRef idx="2">
+            <a:schemeClr val="accent1"/>
+          </a:effectRef>
+          <a:fontRef idx="minor">
+            <a:schemeClr val="lt1"/>
+          </a:fontRef>
+        </p:style>
+        <p:txBody>
+          <a:bodyPr rtlCol="0" anchor="ctr"/>
+          <a:lstStyle/>
+          <a:p>
+            <a:pPr algn="ctr"/>
+          </a:p>
+        </p:txBody>
+      </p:sp>
+      <p:sp>
+        <p:nvSpPr>
+          <p:cNvPr id="7" name="Rectangle 6"/>
+          <p:cNvSpPr/>
+          <p:nvPr/>
+        </p:nvSpPr>
+        <p:spPr>
+          <a:xfrm>
+            <a:off x="640080" y="1874519"/>
+            <a:ext cx="2587752" cy="91440"/>
+          </a:xfrm>
+          <a:prstGeom prst="rect">
+            <a:avLst/>
+          </a:prstGeom>
+          <a:solidFill>
+            <a:srgbClr val="1D4ED8"/>
+          </a:solidFill>
+          <a:ln>
+            <a:noFill/>
+          </a:ln>
+          <a:effectLst/>
+        </p:spPr>
+        <p:style>
+          <a:lnRef idx="1">
+            <a:schemeClr val="accent1"/>
+          </a:lnRef>
+          <a:fillRef idx="3">
+            <a:schemeClr val="accent1"/>
+          </a:fillRef>
+          <a:effectRef idx="2">
+            <a:schemeClr val="accent1"/>
+          </a:effectRef>
+          <a:fontRef idx="minor">
+            <a:schemeClr val="lt1"/>
+          </a:fontRef>
+        </p:style>
+        <p:txBody>
+          <a:bodyPr rtlCol="0" anchor="ctr"/>
+          <a:lstStyle/>
+          <a:p>
+            <a:pPr algn="ctr"/>
+          </a:p>
+        </p:txBody>
+      </p:sp>
+      <p:sp>
+        <p:nvSpPr>
+          <p:cNvPr id="8" name="TextBox 7"/>
+          <p:cNvSpPr txBox="1"/>
+          <p:nvPr/>
+        </p:nvSpPr>
+        <p:spPr>
+          <a:xfrm>
+            <a:off x="877824" y="2057399"/>
+            <a:ext cx="2221992" cy="502920"/>
+          </a:xfrm>
+          <a:prstGeom prst="rect">
+            <a:avLst/>
+          </a:prstGeom>
+          <a:noFill/>
+        </p:spPr>
+        <p:txBody>
+          <a:bodyPr wrap="square" anchor="t" lIns="25400" rIns="25400" tIns="25400" bIns="25400">
+            <a:spAutoFit/>
+          </a:bodyPr>
+          <a:lstStyle/>
+          <a:p>
+            <a:pPr algn="l">
+              <a:lnSpc>
+                <a:spcPct val="106000"/>
+              </a:lnSpc>
+            </a:pPr>
+            <a:r>
+              <a:rPr sz="3000" b="1">
+                <a:solidFill>
+                  <a:srgbClr val="1D4ED8"/>
+                </a:solidFill>
+                <a:latin typeface="Calibri"/>
+              </a:rPr>
+              <a:t>31%</a:t>
+            </a:r>
+          </a:p>
+        </p:txBody>
+      </p:sp>
+      <p:sp>
+        <p:nvSpPr>
+          <p:cNvPr id="9" name="TextBox 8"/>
+          <p:cNvSpPr txBox="1"/>
+          <p:nvPr/>
+        </p:nvSpPr>
+        <p:spPr>
+          <a:xfrm>
+            <a:off x="877824" y="2606039"/>
+            <a:ext cx="2176272" cy="594360"/>
+          </a:xfrm>
+          <a:prstGeom prst="rect">
+            <a:avLst/>
+          </a:prstGeom>
+          <a:noFill/>
+        </p:spPr>
+        <p:txBody>
+          <a:bodyPr wrap="square" anchor="t" lIns="25400" rIns="25400" tIns="25400" bIns="25400">
+            <a:spAutoFit/>
+          </a:bodyPr>
+          <a:lstStyle/>
+          <a:p>
+            <a:pPr algn="l">
+              <a:lnSpc>
+                <a:spcPct val="115000"/>
+              </a:lnSpc>
+            </a:pPr>
+            <a:r>
+              <a:rPr sz="1050" b="1">
+                <a:solidFill>
+                  <a:srgbClr val="0F172A"/>
+                </a:solidFill>
+                <a:latin typeface="Calibri"/>
+              </a:rPr>
+              <a:t>average HVAC energy saving from Guideline 36 sequences, against a baseline of existing practice</a:t>
+            </a:r>
+          </a:p>
+        </p:txBody>
+      </p:sp>
+      <p:sp>
+        <p:nvSpPr>
+          <p:cNvPr id="10" name="TextBox 9"/>
+          <p:cNvSpPr txBox="1"/>
+          <p:nvPr/>
+        </p:nvSpPr>
+        <p:spPr>
+          <a:xfrm>
+            <a:off x="877824" y="3246119"/>
+            <a:ext cx="2176272" cy="502920"/>
+          </a:xfrm>
+          <a:prstGeom prst="rect">
+            <a:avLst/>
+          </a:prstGeom>
+          <a:noFill/>
+        </p:spPr>
+        <p:txBody>
+          <a:bodyPr wrap="square" anchor="t" lIns="25400" rIns="25400" tIns="25400" bIns="25400">
+            <a:spAutoFit/>
+          </a:bodyPr>
+          <a:lstStyle/>
+          <a:p>
+            <a:pPr algn="l">
+              <a:lnSpc>
+                <a:spcPct val="115000"/>
+              </a:lnSpc>
+            </a:pPr>
+            <a:r>
+              <a:rPr sz="800" b="0">
+                <a:solidFill>
+                  <a:srgbClr val="64748B"/>
+                </a:solidFill>
+                <a:latin typeface="Calibri"/>
+              </a:rPr>
+              <a:t>Berkeley Lab, multi-zone VAV simulated in Spawn of EnergyPlus, medium office. J. Building Performance Simulation, 2022</a:t>
+            </a:r>
+          </a:p>
+        </p:txBody>
+      </p:sp>
+      <p:sp>
+        <p:nvSpPr>
+          <p:cNvPr id="11" name="Rounded Rectangle 10"/>
+          <p:cNvSpPr/>
+          <p:nvPr/>
+        </p:nvSpPr>
+        <p:spPr>
+          <a:xfrm>
+            <a:off x="3401568" y="1874519"/>
+            <a:ext cx="2587752" cy="1920240"/>
+          </a:xfrm>
+          <a:prstGeom prst="roundRect">
+            <a:avLst/>
+          </a:prstGeom>
+          <a:solidFill>
+            <a:srgbClr val="FFFFFF"/>
+          </a:solidFill>
+          <a:ln w="12700">
+            <a:solidFill>
+              <a:srgbClr val="E2E8F0"/>
+            </a:solidFill>
+          </a:ln>
+          <a:effectLst/>
+        </p:spPr>
+        <p:style>
+          <a:lnRef idx="1">
+            <a:schemeClr val="accent1"/>
+          </a:lnRef>
+          <a:fillRef idx="3">
+            <a:schemeClr val="accent1"/>
+          </a:fillRef>
+          <a:effectRef idx="2">
+            <a:schemeClr val="accent1"/>
+          </a:effectRef>
+          <a:fontRef idx="minor">
+            <a:schemeClr val="lt1"/>
+          </a:fontRef>
+        </p:style>
+        <p:txBody>
+          <a:bodyPr rtlCol="0" anchor="ctr"/>
+          <a:lstStyle/>
+          <a:p>
+            <a:pPr algn="ctr"/>
+          </a:p>
+        </p:txBody>
+      </p:sp>
+      <p:sp>
+        <p:nvSpPr>
+          <p:cNvPr id="12" name="Rectangle 11"/>
+          <p:cNvSpPr/>
+          <p:nvPr/>
+        </p:nvSpPr>
+        <p:spPr>
+          <a:xfrm>
+            <a:off x="3401568" y="1874519"/>
+            <a:ext cx="2587752" cy="91440"/>
+          </a:xfrm>
+          <a:prstGeom prst="rect">
+            <a:avLst/>
+          </a:prstGeom>
+          <a:solidFill>
+            <a:srgbClr val="047857"/>
+          </a:solidFill>
+          <a:ln>
+            <a:noFill/>
+          </a:ln>
+          <a:effectLst/>
+        </p:spPr>
+        <p:style>
+          <a:lnRef idx="1">
+            <a:schemeClr val="accent1"/>
+          </a:lnRef>
+          <a:fillRef idx="3">
+            <a:schemeClr val="accent1"/>
+          </a:fillRef>
+          <a:effectRef idx="2">
+            <a:schemeClr val="accent1"/>
+          </a:effectRef>
+          <a:fontRef idx="minor">
+            <a:schemeClr val="lt1"/>
+          </a:fontRef>
+        </p:style>
+        <p:txBody>
+          <a:bodyPr rtlCol="0" anchor="ctr"/>
+          <a:lstStyle/>
+          <a:p>
+            <a:pPr algn="ctr"/>
+          </a:p>
+        </p:txBody>
+      </p:sp>
+      <p:sp>
+        <p:nvSpPr>
+          <p:cNvPr id="13" name="TextBox 12"/>
+          <p:cNvSpPr txBox="1"/>
+          <p:nvPr/>
+        </p:nvSpPr>
+        <p:spPr>
+          <a:xfrm>
+            <a:off x="3639312" y="2057399"/>
+            <a:ext cx="2221992" cy="502920"/>
+          </a:xfrm>
+          <a:prstGeom prst="rect">
+            <a:avLst/>
+          </a:prstGeom>
+          <a:noFill/>
+        </p:spPr>
+        <p:txBody>
+          <a:bodyPr wrap="square" anchor="t" lIns="25400" rIns="25400" tIns="25400" bIns="25400">
+            <a:spAutoFit/>
+          </a:bodyPr>
+          <a:lstStyle/>
+          <a:p>
+            <a:pPr algn="l">
+              <a:lnSpc>
+                <a:spcPct val="106000"/>
+              </a:lnSpc>
+            </a:pPr>
+            <a:r>
+              <a:rPr sz="3000" b="1">
+                <a:solidFill>
+                  <a:srgbClr val="047857"/>
+                </a:solidFill>
+                <a:latin typeface="Calibri"/>
+              </a:rPr>
+              <a:t>9%</a:t>
+            </a:r>
+          </a:p>
+        </p:txBody>
+      </p:sp>
+      <p:sp>
+        <p:nvSpPr>
+          <p:cNvPr id="14" name="TextBox 13"/>
+          <p:cNvSpPr txBox="1"/>
+          <p:nvPr/>
+        </p:nvSpPr>
+        <p:spPr>
+          <a:xfrm>
+            <a:off x="3639312" y="2606039"/>
+            <a:ext cx="2176272" cy="594360"/>
+          </a:xfrm>
+          <a:prstGeom prst="rect">
+            <a:avLst/>
+          </a:prstGeom>
+          <a:noFill/>
+        </p:spPr>
+        <p:txBody>
+          <a:bodyPr wrap="square" anchor="t" lIns="25400" rIns="25400" tIns="25400" bIns="25400">
+            <a:spAutoFit/>
+          </a:bodyPr>
+          <a:lstStyle/>
+          <a:p>
+            <a:pPr algn="l">
+              <a:lnSpc>
+                <a:spcPct val="115000"/>
+              </a:lnSpc>
+            </a:pPr>
+            <a:r>
+              <a:rPr sz="1050" b="1">
+                <a:solidFill>
+                  <a:srgbClr val="0F172A"/>
+                </a:solidFill>
+                <a:latin typeface="Calibri"/>
+              </a:rPr>
+              <a:t>median whole-building saving from fault detection, range 1–28%, two-year payback</a:t>
+            </a:r>
+          </a:p>
+        </p:txBody>
+      </p:sp>
+      <p:sp>
+        <p:nvSpPr>
+          <p:cNvPr id="15" name="TextBox 14"/>
+          <p:cNvSpPr txBox="1"/>
+          <p:nvPr/>
+        </p:nvSpPr>
+        <p:spPr>
+          <a:xfrm>
+            <a:off x="3639312" y="3246119"/>
+            <a:ext cx="2176272" cy="502920"/>
+          </a:xfrm>
+          <a:prstGeom prst="rect">
+            <a:avLst/>
+          </a:prstGeom>
+          <a:noFill/>
+        </p:spPr>
+        <p:txBody>
+          <a:bodyPr wrap="square" anchor="t" lIns="25400" rIns="25400" tIns="25400" bIns="25400">
+            <a:spAutoFit/>
+          </a:bodyPr>
+          <a:lstStyle/>
+          <a:p>
+            <a:pPr algn="l">
+              <a:lnSpc>
+                <a:spcPct val="115000"/>
+              </a:lnSpc>
+            </a:pPr>
+            <a:r>
+              <a:rPr sz="800" b="0">
+                <a:solidFill>
+                  <a:srgbClr val="64748B"/>
+                </a:solidFill>
+                <a:latin typeface="Calibri"/>
+              </a:rPr>
+              <a:t>Berkeley Lab Smart Energy Analytics Campaign — 6,500 buildings, over half a billion sq ft</a:t>
+            </a:r>
+          </a:p>
+        </p:txBody>
+      </p:sp>
+      <p:sp>
+        <p:nvSpPr>
+          <p:cNvPr id="16" name="Rounded Rectangle 15"/>
+          <p:cNvSpPr/>
+          <p:nvPr/>
+        </p:nvSpPr>
+        <p:spPr>
+          <a:xfrm>
+            <a:off x="6163056" y="1874519"/>
+            <a:ext cx="2587752" cy="1920240"/>
+          </a:xfrm>
+          <a:prstGeom prst="roundRect">
+            <a:avLst/>
+          </a:prstGeom>
+          <a:solidFill>
+            <a:srgbClr val="FFFFFF"/>
+          </a:solidFill>
+          <a:ln w="12700">
+            <a:solidFill>
+              <a:srgbClr val="E2E8F0"/>
+            </a:solidFill>
+          </a:ln>
+          <a:effectLst/>
+        </p:spPr>
+        <p:style>
+          <a:lnRef idx="1">
+            <a:schemeClr val="accent1"/>
+          </a:lnRef>
+          <a:fillRef idx="3">
+            <a:schemeClr val="accent1"/>
+          </a:fillRef>
+          <a:effectRef idx="2">
+            <a:schemeClr val="accent1"/>
+          </a:effectRef>
+          <a:fontRef idx="minor">
+            <a:schemeClr val="lt1"/>
+          </a:fontRef>
+        </p:style>
+        <p:txBody>
+          <a:bodyPr rtlCol="0" anchor="ctr"/>
+          <a:lstStyle/>
+          <a:p>
+            <a:pPr algn="ctr"/>
+          </a:p>
+        </p:txBody>
+      </p:sp>
+      <p:sp>
+        <p:nvSpPr>
+          <p:cNvPr id="17" name="Rectangle 16"/>
+          <p:cNvSpPr/>
+          <p:nvPr/>
+        </p:nvSpPr>
+        <p:spPr>
+          <a:xfrm>
+            <a:off x="6163056" y="1874519"/>
+            <a:ext cx="2587752" cy="91440"/>
+          </a:xfrm>
+          <a:prstGeom prst="rect">
+            <a:avLst/>
+          </a:prstGeom>
+          <a:solidFill>
+            <a:srgbClr val="B45309"/>
+          </a:solidFill>
+          <a:ln>
+            <a:noFill/>
+          </a:ln>
+          <a:effectLst/>
+        </p:spPr>
+        <p:style>
+          <a:lnRef idx="1">
+            <a:schemeClr val="accent1"/>
+          </a:lnRef>
+          <a:fillRef idx="3">
+            <a:schemeClr val="accent1"/>
+          </a:fillRef>
+          <a:effectRef idx="2">
+            <a:schemeClr val="accent1"/>
+          </a:effectRef>
+          <a:fontRef idx="minor">
+            <a:schemeClr val="lt1"/>
+          </a:fontRef>
+        </p:style>
+        <p:txBody>
+          <a:bodyPr rtlCol="0" anchor="ctr"/>
+          <a:lstStyle/>
+          <a:p>
+            <a:pPr algn="ctr"/>
+          </a:p>
+        </p:txBody>
+      </p:sp>
+      <p:sp>
+        <p:nvSpPr>
+          <p:cNvPr id="18" name="TextBox 17"/>
+          <p:cNvSpPr txBox="1"/>
+          <p:nvPr/>
+        </p:nvSpPr>
+        <p:spPr>
+          <a:xfrm>
+            <a:off x="6400800" y="2057399"/>
+            <a:ext cx="2221992" cy="502920"/>
+          </a:xfrm>
+          <a:prstGeom prst="rect">
+            <a:avLst/>
+          </a:prstGeom>
+          <a:noFill/>
+        </p:spPr>
+        <p:txBody>
+          <a:bodyPr wrap="square" anchor="t" lIns="25400" rIns="25400" tIns="25400" bIns="25400">
+            <a:spAutoFit/>
+          </a:bodyPr>
+          <a:lstStyle/>
+          <a:p>
+            <a:pPr algn="l">
+              <a:lnSpc>
+                <a:spcPct val="106000"/>
+              </a:lnSpc>
+            </a:pPr>
+            <a:r>
+              <a:rPr sz="3000" b="1">
+                <a:solidFill>
+                  <a:srgbClr val="B45309"/>
+                </a:solidFill>
+                <a:latin typeface="Calibri"/>
+              </a:rPr>
+              <a:t>64%</a:t>
+            </a:r>
+          </a:p>
+        </p:txBody>
+      </p:sp>
+      <p:sp>
+        <p:nvSpPr>
+          <p:cNvPr id="19" name="TextBox 18"/>
+          <p:cNvSpPr txBox="1"/>
+          <p:nvPr/>
+        </p:nvSpPr>
+        <p:spPr>
+          <a:xfrm>
+            <a:off x="6400800" y="2606039"/>
+            <a:ext cx="2176272" cy="594360"/>
+          </a:xfrm>
+          <a:prstGeom prst="rect">
+            <a:avLst/>
+          </a:prstGeom>
+          <a:noFill/>
+        </p:spPr>
+        <p:txBody>
+          <a:bodyPr wrap="square" anchor="t" lIns="25400" rIns="25400" tIns="25400" bIns="25400">
+            <a:spAutoFit/>
+          </a:bodyPr>
+          <a:lstStyle/>
+          <a:p>
+            <a:pPr algn="l">
+              <a:lnSpc>
+                <a:spcPct val="115000"/>
+              </a:lnSpc>
+            </a:pPr>
+            <a:r>
+              <a:rPr sz="1050" b="1">
+                <a:solidFill>
+                  <a:srgbClr val="0F172A"/>
+                </a:solidFill>
+                <a:latin typeface="Calibri"/>
+              </a:rPr>
+              <a:t>of economizers found faulty in the field — free cooling paid for and never delivered</a:t>
+            </a:r>
+          </a:p>
+        </p:txBody>
+      </p:sp>
+      <p:sp>
+        <p:nvSpPr>
+          <p:cNvPr id="20" name="TextBox 19"/>
+          <p:cNvSpPr txBox="1"/>
+          <p:nvPr/>
+        </p:nvSpPr>
+        <p:spPr>
+          <a:xfrm>
+            <a:off x="6400800" y="3246119"/>
+            <a:ext cx="2176272" cy="502920"/>
+          </a:xfrm>
+          <a:prstGeom prst="rect">
+            <a:avLst/>
+          </a:prstGeom>
+          <a:noFill/>
+        </p:spPr>
+        <p:txBody>
+          <a:bodyPr wrap="square" anchor="t" lIns="25400" rIns="25400" tIns="25400" bIns="25400">
+            <a:spAutoFit/>
+          </a:bodyPr>
+          <a:lstStyle/>
+          <a:p>
+            <a:pPr algn="l">
+              <a:lnSpc>
+                <a:spcPct val="115000"/>
+              </a:lnSpc>
+            </a:pPr>
+            <a:r>
+              <a:rPr sz="800" b="0">
+                <a:solidFill>
+                  <a:srgbClr val="64748B"/>
+                </a:solidFill>
+                <a:latin typeface="Calibri"/>
+              </a:rPr>
+              <a:t>New Buildings Institute; a wider literature survey averages 58%, with 25–40% of rooftop units faulty at any moment</a:t>
+            </a:r>
+          </a:p>
+        </p:txBody>
+      </p:sp>
+      <p:sp>
+        <p:nvSpPr>
+          <p:cNvPr id="21" name="Rounded Rectangle 20"/>
+          <p:cNvSpPr/>
+          <p:nvPr/>
+        </p:nvSpPr>
+        <p:spPr>
+          <a:xfrm>
+            <a:off x="8924544" y="1874519"/>
+            <a:ext cx="2587752" cy="1920240"/>
+          </a:xfrm>
+          <a:prstGeom prst="roundRect">
+            <a:avLst/>
+          </a:prstGeom>
+          <a:solidFill>
+            <a:srgbClr val="FFFFFF"/>
+          </a:solidFill>
+          <a:ln w="12700">
+            <a:solidFill>
+              <a:srgbClr val="E2E8F0"/>
+            </a:solidFill>
+          </a:ln>
+          <a:effectLst/>
+        </p:spPr>
+        <p:style>
+          <a:lnRef idx="1">
+            <a:schemeClr val="accent1"/>
+          </a:lnRef>
+          <a:fillRef idx="3">
+            <a:schemeClr val="accent1"/>
+          </a:fillRef>
+          <a:effectRef idx="2">
+            <a:schemeClr val="accent1"/>
+          </a:effectRef>
+          <a:fontRef idx="minor">
+            <a:schemeClr val="lt1"/>
+          </a:fontRef>
+        </p:style>
+        <p:txBody>
+          <a:bodyPr rtlCol="0" anchor="ctr"/>
+          <a:lstStyle/>
+          <a:p>
+            <a:pPr algn="ctr"/>
+          </a:p>
+        </p:txBody>
+      </p:sp>
+      <p:sp>
+        <p:nvSpPr>
+          <p:cNvPr id="22" name="Rectangle 21"/>
+          <p:cNvSpPr/>
+          <p:nvPr/>
+        </p:nvSpPr>
+        <p:spPr>
+          <a:xfrm>
+            <a:off x="8924544" y="1874519"/>
+            <a:ext cx="2587752" cy="91440"/>
+          </a:xfrm>
+          <a:prstGeom prst="rect">
+            <a:avLst/>
+          </a:prstGeom>
+          <a:solidFill>
+            <a:srgbClr val="7C3AED"/>
+          </a:solidFill>
+          <a:ln>
+            <a:noFill/>
+          </a:ln>
+          <a:effectLst/>
+        </p:spPr>
+        <p:style>
+          <a:lnRef idx="1">
+            <a:schemeClr val="accent1"/>
+          </a:lnRef>
+          <a:fillRef idx="3">
+            <a:schemeClr val="accent1"/>
+          </a:fillRef>
+          <a:effectRef idx="2">
+            <a:schemeClr val="accent1"/>
+          </a:effectRef>
+          <a:fontRef idx="minor">
+            <a:schemeClr val="lt1"/>
+          </a:fontRef>
+        </p:style>
+        <p:txBody>
+          <a:bodyPr rtlCol="0" anchor="ctr"/>
+          <a:lstStyle/>
+          <a:p>
+            <a:pPr algn="ctr"/>
+          </a:p>
+        </p:txBody>
+      </p:sp>
+      <p:sp>
+        <p:nvSpPr>
+          <p:cNvPr id="23" name="TextBox 22"/>
+          <p:cNvSpPr txBox="1"/>
+          <p:nvPr/>
+        </p:nvSpPr>
+        <p:spPr>
+          <a:xfrm>
+            <a:off x="9162288" y="2057399"/>
+            <a:ext cx="2221992" cy="502920"/>
+          </a:xfrm>
+          <a:prstGeom prst="rect">
+            <a:avLst/>
+          </a:prstGeom>
+          <a:noFill/>
+        </p:spPr>
+        <p:txBody>
+          <a:bodyPr wrap="square" anchor="t" lIns="25400" rIns="25400" tIns="25400" bIns="25400">
+            <a:spAutoFit/>
+          </a:bodyPr>
+          <a:lstStyle/>
+          <a:p>
+            <a:pPr algn="l">
+              <a:lnSpc>
+                <a:spcPct val="106000"/>
+              </a:lnSpc>
+            </a:pPr>
+            <a:r>
+              <a:rPr sz="3000" b="1">
+                <a:solidFill>
+                  <a:srgbClr val="7C3AED"/>
+                </a:solidFill>
+                <a:latin typeface="Calibri"/>
+              </a:rPr>
+              <a:t>20–41%</a:t>
+            </a:r>
+          </a:p>
+        </p:txBody>
+      </p:sp>
+      <p:sp>
+        <p:nvSpPr>
+          <p:cNvPr id="24" name="TextBox 23"/>
+          <p:cNvSpPr txBox="1"/>
+          <p:nvPr/>
+        </p:nvSpPr>
+        <p:spPr>
+          <a:xfrm>
+            <a:off x="9162288" y="2606039"/>
+            <a:ext cx="2176272" cy="594360"/>
+          </a:xfrm>
+          <a:prstGeom prst="rect">
+            <a:avLst/>
+          </a:prstGeom>
+          <a:noFill/>
+        </p:spPr>
+        <p:txBody>
+          <a:bodyPr wrap="square" anchor="t" lIns="25400" rIns="25400" tIns="25400" bIns="25400">
+            <a:spAutoFit/>
+          </a:bodyPr>
+          <a:lstStyle/>
+          <a:p>
+            <a:pPr algn="l">
+              <a:lnSpc>
+                <a:spcPct val="115000"/>
+              </a:lnSpc>
+            </a:pPr>
+            <a:r>
+              <a:rPr sz="1050" b="1">
+                <a:solidFill>
+                  <a:srgbClr val="0F172A"/>
+                </a:solidFill>
+                <a:latin typeface="Calibri"/>
+              </a:rPr>
+              <a:t>seasonal saving from supervisory setpoint resets: 20% cooling, 18% shoulder, 41% heating</a:t>
+            </a:r>
+          </a:p>
+        </p:txBody>
+      </p:sp>
+      <p:sp>
+        <p:nvSpPr>
+          <p:cNvPr id="25" name="TextBox 24"/>
+          <p:cNvSpPr txBox="1"/>
+          <p:nvPr/>
+        </p:nvSpPr>
+        <p:spPr>
+          <a:xfrm>
+            <a:off x="9162288" y="3246119"/>
+            <a:ext cx="2176272" cy="502920"/>
+          </a:xfrm>
+          <a:prstGeom prst="rect">
+            <a:avLst/>
+          </a:prstGeom>
+          <a:noFill/>
+        </p:spPr>
+        <p:txBody>
+          <a:bodyPr wrap="square" anchor="t" lIns="25400" rIns="25400" tIns="25400" bIns="25400">
+            <a:spAutoFit/>
+          </a:bodyPr>
+          <a:lstStyle/>
+          <a:p>
+            <a:pPr algn="l">
+              <a:lnSpc>
+                <a:spcPct val="115000"/>
+              </a:lnSpc>
+            </a:pPr>
+            <a:r>
+              <a:rPr sz="800" b="0">
+                <a:solidFill>
+                  <a:srgbClr val="64748B"/>
+                </a:solidFill>
+                <a:latin typeface="Calibri"/>
+              </a:rPr>
+              <a:t>PNNL, large-office emulator, Chicago, 2024 — airside and plant-side resets combined</a:t>
+            </a:r>
+          </a:p>
+        </p:txBody>
+      </p:sp>
+      <p:sp>
+        <p:nvSpPr>
+          <p:cNvPr id="26" name="Rounded Rectangle 25"/>
+          <p:cNvSpPr/>
+          <p:nvPr/>
+        </p:nvSpPr>
+        <p:spPr>
+          <a:xfrm>
+            <a:off x="640080" y="4041648"/>
+            <a:ext cx="5349240" cy="1783080"/>
+          </a:xfrm>
+          <a:prstGeom prst="roundRect">
+            <a:avLst/>
+          </a:prstGeom>
+          <a:solidFill>
+            <a:srgbClr val="FFFFFF"/>
+          </a:solidFill>
+          <a:ln w="12700">
+            <a:solidFill>
+              <a:srgbClr val="E2E8F0"/>
+            </a:solidFill>
+          </a:ln>
+          <a:effectLst/>
+        </p:spPr>
+        <p:style>
+          <a:lnRef idx="1">
+            <a:schemeClr val="accent1"/>
+          </a:lnRef>
+          <a:fillRef idx="3">
+            <a:schemeClr val="accent1"/>
+          </a:fillRef>
+          <a:effectRef idx="2">
+            <a:schemeClr val="accent1"/>
+          </a:effectRef>
+          <a:fontRef idx="minor">
+            <a:schemeClr val="lt1"/>
+          </a:fontRef>
+        </p:style>
+        <p:txBody>
+          <a:bodyPr rtlCol="0" anchor="ctr"/>
+          <a:lstStyle/>
+          <a:p>
+            <a:pPr algn="ctr"/>
+          </a:p>
+        </p:txBody>
+      </p:sp>
+      <p:sp>
+        <p:nvSpPr>
+          <p:cNvPr id="27" name="TextBox 26"/>
+          <p:cNvSpPr txBox="1"/>
+          <p:nvPr/>
+        </p:nvSpPr>
+        <p:spPr>
+          <a:xfrm>
+            <a:off x="896112" y="4169663"/>
+            <a:ext cx="4846320" cy="292608"/>
+          </a:xfrm>
+          <a:prstGeom prst="rect">
+            <a:avLst/>
+          </a:prstGeom>
+          <a:noFill/>
+        </p:spPr>
+        <p:txBody>
+          <a:bodyPr wrap="square" anchor="t" lIns="25400" rIns="25400" tIns="25400" bIns="25400">
+            <a:spAutoFit/>
+          </a:bodyPr>
+          <a:lstStyle/>
+          <a:p>
+            <a:pPr algn="l">
+              <a:lnSpc>
+                <a:spcPct val="106000"/>
+              </a:lnSpc>
+            </a:pPr>
+            <a:r>
+              <a:rPr sz="1400" b="1">
+                <a:solidFill>
+                  <a:srgbClr val="047857"/>
+                </a:solidFill>
+                <a:latin typeface="Calibri"/>
+              </a:rPr>
+              <a:t>Where the saving actually comes from</a:t>
+            </a:r>
+          </a:p>
+        </p:txBody>
+      </p:sp>
+      <p:sp>
+        <p:nvSpPr>
+          <p:cNvPr id="28" name="TextBox 27"/>
+          <p:cNvSpPr txBox="1"/>
+          <p:nvPr/>
+        </p:nvSpPr>
+        <p:spPr>
+          <a:xfrm>
+            <a:off x="896112" y="4526280"/>
+            <a:ext cx="4892040" cy="1234440"/>
+          </a:xfrm>
+          <a:prstGeom prst="rect">
+            <a:avLst/>
+          </a:prstGeom>
+          <a:noFill/>
+        </p:spPr>
+        <p:txBody>
+          <a:bodyPr wrap="square" anchor="t" lIns="25400" rIns="25400" tIns="25400" bIns="25400">
+            <a:spAutoFit/>
+          </a:bodyPr>
+          <a:lstStyle/>
+          <a:p>
+            <a:pPr algn="l">
+              <a:lnSpc>
+                <a:spcPct val="120000"/>
+              </a:lnSpc>
+            </a:pPr>
+            <a:r>
+              <a:rPr sz="1050" b="0">
+                <a:solidFill>
+                  <a:srgbClr val="475569"/>
+                </a:solidFill>
+                <a:latin typeface="Calibri"/>
+              </a:rPr>
+              <a:t>•  Free-cooling hours TAKEN rather than missed, because the decision is made on energy rather than temperature alone.</a:t>
+            </a:r>
+          </a:p>
+          <a:p>
+            <a:pPr algn="l">
+              <a:lnSpc>
+                <a:spcPct val="120000"/>
+              </a:lnSpc>
+            </a:pPr>
+            <a:r>
+              <a:rPr sz="1050" b="0">
+                <a:solidFill>
+                  <a:srgbClr val="475569"/>
+                </a:solidFill>
+                <a:latin typeface="Calibri"/>
+              </a:rPr>
+              <a:t>•  Outside air delivered at the rate 62.1 requires — not quietly at double it.</a:t>
+            </a:r>
+          </a:p>
+          <a:p>
+            <a:pPr algn="l">
+              <a:lnSpc>
+                <a:spcPct val="120000"/>
+              </a:lnSpc>
+            </a:pPr>
+            <a:r>
+              <a:rPr sz="1050" b="0">
+                <a:solidFill>
+                  <a:srgbClr val="475569"/>
+                </a:solidFill>
+                <a:latin typeface="Calibri"/>
+              </a:rPr>
+              <a:t>•  Supply air reset to follow the load instead of one fixed setpoint all year.</a:t>
+            </a:r>
+          </a:p>
+          <a:p>
+            <a:pPr algn="l">
+              <a:lnSpc>
+                <a:spcPct val="120000"/>
+              </a:lnSpc>
+            </a:pPr>
+            <a:r>
+              <a:rPr sz="1050" b="0">
+                <a:solidFill>
+                  <a:srgbClr val="475569"/>
+                </a:solidFill>
+                <a:latin typeface="Calibri"/>
+              </a:rPr>
+              <a:t>•  Coil, damper and sensor faults caught in days rather than at the next seasonal complaint.</a:t>
+            </a:r>
+          </a:p>
+        </p:txBody>
+      </p:sp>
+      <p:sp>
+        <p:nvSpPr>
+          <p:cNvPr id="29" name="Rounded Rectangle 28"/>
+          <p:cNvSpPr/>
+          <p:nvPr/>
+        </p:nvSpPr>
+        <p:spPr>
+          <a:xfrm>
+            <a:off x="6199632" y="4041648"/>
+            <a:ext cx="5349240" cy="1783080"/>
+          </a:xfrm>
+          <a:prstGeom prst="roundRect">
+            <a:avLst/>
+          </a:prstGeom>
+          <a:solidFill>
+            <a:srgbClr val="FFFFFF"/>
+          </a:solidFill>
+          <a:ln w="12700">
+            <a:solidFill>
+              <a:srgbClr val="E2E8F0"/>
+            </a:solidFill>
+          </a:ln>
+          <a:effectLst/>
+        </p:spPr>
+        <p:style>
+          <a:lnRef idx="1">
+            <a:schemeClr val="accent1"/>
+          </a:lnRef>
+          <a:fillRef idx="3">
+            <a:schemeClr val="accent1"/>
+          </a:fillRef>
+          <a:effectRef idx="2">
+            <a:schemeClr val="accent1"/>
+          </a:effectRef>
+          <a:fontRef idx="minor">
+            <a:schemeClr val="lt1"/>
+          </a:fontRef>
+        </p:style>
+        <p:txBody>
+          <a:bodyPr rtlCol="0" anchor="ctr"/>
+          <a:lstStyle/>
+          <a:p>
+            <a:pPr algn="ctr"/>
+          </a:p>
+        </p:txBody>
+      </p:sp>
+      <p:sp>
+        <p:nvSpPr>
+          <p:cNvPr id="30" name="TextBox 29"/>
+          <p:cNvSpPr txBox="1"/>
+          <p:nvPr/>
+        </p:nvSpPr>
+        <p:spPr>
+          <a:xfrm>
+            <a:off x="6455664" y="4169663"/>
+            <a:ext cx="4846320" cy="292608"/>
+          </a:xfrm>
+          <a:prstGeom prst="rect">
+            <a:avLst/>
+          </a:prstGeom>
+          <a:noFill/>
+        </p:spPr>
+        <p:txBody>
+          <a:bodyPr wrap="square" anchor="t" lIns="25400" rIns="25400" tIns="25400" bIns="25400">
+            <a:spAutoFit/>
+          </a:bodyPr>
+          <a:lstStyle/>
+          <a:p>
+            <a:pPr algn="l">
+              <a:lnSpc>
+                <a:spcPct val="106000"/>
+              </a:lnSpc>
+            </a:pPr>
+            <a:r>
+              <a:rPr sz="1400" b="1">
+                <a:solidFill>
+                  <a:srgbClr val="B45309"/>
+                </a:solidFill>
+                <a:latin typeface="Calibri"/>
+              </a:rPr>
+              <a:t>Read these numbers honestly</a:t>
+            </a:r>
+          </a:p>
+        </p:txBody>
+      </p:sp>
+      <p:sp>
+        <p:nvSpPr>
+          <p:cNvPr id="31" name="TextBox 30"/>
+          <p:cNvSpPr txBox="1"/>
+          <p:nvPr/>
+        </p:nvSpPr>
+        <p:spPr>
+          <a:xfrm>
+            <a:off x="6455664" y="4526280"/>
+            <a:ext cx="4892040" cy="1234440"/>
+          </a:xfrm>
+          <a:prstGeom prst="rect">
+            <a:avLst/>
+          </a:prstGeom>
+          <a:noFill/>
+        </p:spPr>
+        <p:txBody>
+          <a:bodyPr wrap="square" anchor="t" lIns="25400" rIns="25400" tIns="25400" bIns="25400">
+            <a:spAutoFit/>
+          </a:bodyPr>
+          <a:lstStyle/>
+          <a:p>
+            <a:pPr algn="l">
+              <a:lnSpc>
+                <a:spcPct val="120000"/>
+              </a:lnSpc>
+            </a:pPr>
+            <a:r>
+              <a:rPr sz="1050" b="0">
+                <a:solidFill>
+                  <a:srgbClr val="475569"/>
+                </a:solidFill>
+                <a:latin typeface="Calibri"/>
+              </a:rPr>
+              <a:t>•  They are measure-level results from simulation and field studies — not a guarantee for any one building.</a:t>
+            </a:r>
+          </a:p>
+          <a:p>
+            <a:pPr algn="l">
+              <a:lnSpc>
+                <a:spcPct val="120000"/>
+              </a:lnSpc>
+            </a:pPr>
+            <a:r>
+              <a:rPr sz="1050" b="0">
+                <a:solidFill>
+                  <a:srgbClr val="475569"/>
+                </a:solidFill>
+                <a:latin typeface="Calibri"/>
+              </a:rPr>
+              <a:t>•  They overlap heavily. Do not add them together.</a:t>
+            </a:r>
+          </a:p>
+          <a:p>
+            <a:pPr algn="l">
+              <a:lnSpc>
+                <a:spcPct val="120000"/>
+              </a:lnSpc>
+            </a:pPr>
+            <a:r>
+              <a:rPr sz="1050" b="0">
+                <a:solidFill>
+                  <a:srgbClr val="475569"/>
+                </a:solidFill>
+                <a:latin typeface="Calibri"/>
+              </a:rPr>
+              <a:t>•  The largest savings come from the worst starting points; a well-commissioned building has less to gain.</a:t>
+            </a:r>
+          </a:p>
+          <a:p>
+            <a:pPr algn="l">
+              <a:lnSpc>
+                <a:spcPct val="120000"/>
+              </a:lnSpc>
+            </a:pPr>
+            <a:r>
+              <a:rPr sz="1050" b="0">
+                <a:solidFill>
+                  <a:srgbClr val="475569"/>
+                </a:solidFill>
+                <a:latin typeface="Calibri"/>
+              </a:rPr>
+              <a:t>•  Enthalpy switching is NOT automatically better. Taylor &amp; Cheng (ASHRAE Journal, 2010) found fixed dry-bulb often wins once humidity-sensor drift is counted — hence the 90.1-2013 sensor limits.</a:t>
+            </a:r>
+          </a:p>
+        </p:txBody>
+      </p:sp>
+      <p:sp>
+        <p:nvSpPr>
+          <p:cNvPr id="32" name="TextBox 31"/>
+          <p:cNvSpPr txBox="1"/>
+          <p:nvPr/>
+        </p:nvSpPr>
+        <p:spPr>
+          <a:xfrm>
+            <a:off x="640080" y="6035040"/>
+            <a:ext cx="10908792" cy="548640"/>
+          </a:xfrm>
+          <a:prstGeom prst="rect">
+            <a:avLst/>
+          </a:prstGeom>
+          <a:noFill/>
+        </p:spPr>
+        <p:txBody>
+          <a:bodyPr wrap="square" anchor="t" lIns="25400" rIns="25400" tIns="25400" bIns="25400">
+            <a:spAutoFit/>
+          </a:bodyPr>
+          <a:lstStyle/>
+          <a:p>
+            <a:pPr algn="ctr">
+              <a:lnSpc>
+                <a:spcPct val="120000"/>
+              </a:lnSpc>
+            </a:pPr>
+            <a:r>
+              <a:rPr sz="1300" b="1">
+                <a:solidFill>
+                  <a:srgbClr val="1D4ED8"/>
+                </a:solidFill>
+                <a:latin typeface="Calibri"/>
+              </a:rPr>
+              <a:t>The chart itself saves nothing. It makes the opportunity visible and the fault obvious — the saving comes from acting on what it shows.</a:t>
+            </a:r>
+          </a:p>
+        </p:txBody>
+      </p:sp>
+    </p:spTree>
+  </p:cSld>
+  <p:clrMapOvr>
+    <a:masterClrMapping/>
+  </p:clrMapOvr>
+</p:sld>
+</file>
+
+<file path=ppt/slides/slide12.xml><?xml version="1.0" encoding="utf-8"?>
 <p:sld xmlns:a="http://schemas.openxmlformats.org/drawingml/2006/main" xmlns:p="http://schemas.openxmlformats.org/presentationml/2006/main" xmlns:r="http://schemas.openxmlformats.org/officeDocument/2006/relationships">
   <p:cSld>
     <p:spTree>

</xml_diff>

<commit_message>
Correct attribution on the savings slide
The four published figures were laid out as if all four were psychrometric-chart
returns. Two are not: the Guideline 36 result is driven mainly by static-pressure
reset, zone minimum airflow and scheduling, and the PNNL result combines airside
with chilled- and hot-water resets that never appear on the chart. The economizer
number is fault prevalence, not a saving at all.

Split into two labelled bands - what the sequences are worth versus what the chart
contributes - with a per-figure note on how much of each is actually on-chart. The
fault-detection case now cites NIST APAR, whose 28 rules are the chart's mass- and
energy-balance geometry. Seasonal resets shown as three separate figures rather
than a spurious 20-41% range.

Co-authored-by: Cursor <cursoragent@cursor.com>
</commit_message>
<xml_diff>
--- a/Psychart-HVAC-ASHRAE-Overview.pptx
+++ b/Psychart-HVAC-ASHRAE-Overview.pptx
@@ -5043,21 +5043,177 @@
                 </a:solidFill>
                 <a:latin typeface="Calibri"/>
               </a:rPr>
-              <a:t>What is it worth?</a:t>
-            </a:r>
-          </a:p>
-        </p:txBody>
-      </p:sp>
-      <p:sp>
-        <p:nvSpPr>
-          <p:cNvPr id="6" name="Rounded Rectangle 5"/>
+              <a:t>What is it worth — and whose credit is it?</a:t>
+            </a:r>
+          </a:p>
+        </p:txBody>
+      </p:sp>
+      <p:sp>
+        <p:nvSpPr>
+          <p:cNvPr id="6" name="TextBox 5"/>
+          <p:cNvSpPr txBox="1"/>
+          <p:nvPr/>
+        </p:nvSpPr>
+        <p:spPr>
+          <a:xfrm>
+            <a:off x="640080" y="1700784"/>
+            <a:ext cx="5349240" cy="256032"/>
+          </a:xfrm>
+          <a:prstGeom prst="rect">
+            <a:avLst/>
+          </a:prstGeom>
+          <a:noFill/>
+        </p:spPr>
+        <p:txBody>
+          <a:bodyPr wrap="square" anchor="t" lIns="25400" rIns="25400" tIns="25400" bIns="25400">
+            <a:spAutoFit/>
+          </a:bodyPr>
+          <a:lstStyle/>
+          <a:p>
+            <a:pPr algn="l">
+              <a:lnSpc>
+                <a:spcPct val="106000"/>
+              </a:lnSpc>
+            </a:pPr>
+            <a:r>
+              <a:rPr sz="1300" b="1">
+                <a:solidFill>
+                  <a:srgbClr val="1D4ED8"/>
+                </a:solidFill>
+                <a:latin typeface="Calibri"/>
+              </a:rPr>
+              <a:t>What good air-side control is worth</a:t>
+            </a:r>
+          </a:p>
+        </p:txBody>
+      </p:sp>
+      <p:sp>
+        <p:nvSpPr>
+          <p:cNvPr id="7" name="TextBox 6"/>
+          <p:cNvSpPr txBox="1"/>
+          <p:nvPr/>
+        </p:nvSpPr>
+        <p:spPr>
+          <a:xfrm>
+            <a:off x="640080" y="1956816"/>
+            <a:ext cx="5212080" cy="347472"/>
+          </a:xfrm>
+          <a:prstGeom prst="rect">
+            <a:avLst/>
+          </a:prstGeom>
+          <a:noFill/>
+        </p:spPr>
+        <p:txBody>
+          <a:bodyPr wrap="square" anchor="t" lIns="25400" rIns="25400" tIns="25400" bIns="25400">
+            <a:spAutoFit/>
+          </a:bodyPr>
+          <a:lstStyle/>
+          <a:p>
+            <a:pPr algn="l">
+              <a:lnSpc>
+                <a:spcPct val="115000"/>
+              </a:lnSpc>
+            </a:pPr>
+            <a:r>
+              <a:rPr sz="1000" b="0">
+                <a:solidFill>
+                  <a:srgbClr val="64748B"/>
+                </a:solidFill>
+                <a:latin typeface="Calibri"/>
+              </a:rPr>
+              <a:t>The prize, and it belongs to the sequences. The chart does not produce these savings — it makes them verifiable.</a:t>
+            </a:r>
+          </a:p>
+        </p:txBody>
+      </p:sp>
+      <p:sp>
+        <p:nvSpPr>
+          <p:cNvPr id="8" name="TextBox 7"/>
+          <p:cNvSpPr txBox="1"/>
+          <p:nvPr/>
+        </p:nvSpPr>
+        <p:spPr>
+          <a:xfrm>
+            <a:off x="6199632" y="1700784"/>
+            <a:ext cx="5349240" cy="256032"/>
+          </a:xfrm>
+          <a:prstGeom prst="rect">
+            <a:avLst/>
+          </a:prstGeom>
+          <a:noFill/>
+        </p:spPr>
+        <p:txBody>
+          <a:bodyPr wrap="square" anchor="t" lIns="25400" rIns="25400" tIns="25400" bIns="25400">
+            <a:spAutoFit/>
+          </a:bodyPr>
+          <a:lstStyle/>
+          <a:p>
+            <a:pPr algn="l">
+              <a:lnSpc>
+                <a:spcPct val="106000"/>
+              </a:lnSpc>
+            </a:pPr>
+            <a:r>
+              <a:rPr sz="1300" b="1">
+                <a:solidFill>
+                  <a:srgbClr val="047857"/>
+                </a:solidFill>
+                <a:latin typeface="Calibri"/>
+              </a:rPr>
+              <a:t>What the chart itself contributes</a:t>
+            </a:r>
+          </a:p>
+        </p:txBody>
+      </p:sp>
+      <p:sp>
+        <p:nvSpPr>
+          <p:cNvPr id="9" name="TextBox 8"/>
+          <p:cNvSpPr txBox="1"/>
+          <p:nvPr/>
+        </p:nvSpPr>
+        <p:spPr>
+          <a:xfrm>
+            <a:off x="6199632" y="1956816"/>
+            <a:ext cx="5212080" cy="347472"/>
+          </a:xfrm>
+          <a:prstGeom prst="rect">
+            <a:avLst/>
+          </a:prstGeom>
+          <a:noFill/>
+        </p:spPr>
+        <p:txBody>
+          <a:bodyPr wrap="square" anchor="t" lIns="25400" rIns="25400" tIns="25400" bIns="25400">
+            <a:spAutoFit/>
+          </a:bodyPr>
+          <a:lstStyle/>
+          <a:p>
+            <a:pPr algn="l">
+              <a:lnSpc>
+                <a:spcPct val="115000"/>
+              </a:lnSpc>
+            </a:pPr>
+            <a:r>
+              <a:rPr sz="1000" b="0">
+                <a:solidFill>
+                  <a:srgbClr val="64748B"/>
+                </a:solidFill>
+                <a:latin typeface="Calibri"/>
+              </a:rPr>
+              <a:t>Visibility: the missed hours and the broken parts that a temperature trend hides.</a:t>
+            </a:r>
+          </a:p>
+        </p:txBody>
+      </p:sp>
+      <p:sp>
+        <p:nvSpPr>
+          <p:cNvPr id="10" name="Rounded Rectangle 9"/>
           <p:cNvSpPr/>
           <p:nvPr/>
         </p:nvSpPr>
         <p:spPr>
           <a:xfrm>
-            <a:off x="640080" y="1874519"/>
-            <a:ext cx="2587752" cy="1920240"/>
+            <a:off x="640080" y="2340864"/>
+            <a:ext cx="2551176" cy="1783080"/>
           </a:xfrm>
           <a:prstGeom prst="roundRect">
             <a:avLst/>
@@ -5096,14 +5252,14 @@
       </p:sp>
       <p:sp>
         <p:nvSpPr>
-          <p:cNvPr id="7" name="Rectangle 6"/>
+          <p:cNvPr id="11" name="Rectangle 10"/>
           <p:cNvSpPr/>
           <p:nvPr/>
         </p:nvSpPr>
         <p:spPr>
           <a:xfrm>
-            <a:off x="640080" y="1874519"/>
-            <a:ext cx="2587752" cy="91440"/>
+            <a:off x="640080" y="2340864"/>
+            <a:ext cx="2551176" cy="82296"/>
           </a:xfrm>
           <a:prstGeom prst="rect">
             <a:avLst/>
@@ -5140,14 +5296,14 @@
       </p:sp>
       <p:sp>
         <p:nvSpPr>
-          <p:cNvPr id="8" name="TextBox 7"/>
-          <p:cNvSpPr txBox="1"/>
-          <p:nvPr/>
-        </p:nvSpPr>
-        <p:spPr>
-          <a:xfrm>
-            <a:off x="877824" y="2057399"/>
-            <a:ext cx="2221992" cy="502920"/>
+          <p:cNvPr id="12" name="TextBox 11"/>
+          <p:cNvSpPr txBox="1"/>
+          <p:nvPr/>
+        </p:nvSpPr>
+        <p:spPr>
+          <a:xfrm>
+            <a:off x="822960" y="2505456"/>
+            <a:ext cx="2185416" cy="457200"/>
           </a:xfrm>
           <a:prstGeom prst="rect">
             <a:avLst/>
@@ -5166,7 +5322,7 @@
               </a:lnSpc>
             </a:pPr>
             <a:r>
-              <a:rPr sz="3000" b="1">
+              <a:rPr sz="2600" b="1">
                 <a:solidFill>
                   <a:srgbClr val="1D4ED8"/>
                 </a:solidFill>
@@ -5179,14 +5335,14 @@
       </p:sp>
       <p:sp>
         <p:nvSpPr>
-          <p:cNvPr id="9" name="TextBox 8"/>
-          <p:cNvSpPr txBox="1"/>
-          <p:nvPr/>
-        </p:nvSpPr>
-        <p:spPr>
-          <a:xfrm>
-            <a:off x="877824" y="2606039"/>
-            <a:ext cx="2176272" cy="594360"/>
+          <p:cNvPr id="13" name="TextBox 12"/>
+          <p:cNvSpPr txBox="1"/>
+          <p:nvPr/>
+        </p:nvSpPr>
+        <p:spPr>
+          <a:xfrm>
+            <a:off x="822960" y="2980944"/>
+            <a:ext cx="2221992" cy="457200"/>
           </a:xfrm>
           <a:prstGeom prst="rect">
             <a:avLst/>
@@ -5201,31 +5357,31 @@
           <a:p>
             <a:pPr algn="l">
               <a:lnSpc>
-                <a:spcPct val="115000"/>
-              </a:lnSpc>
-            </a:pPr>
-            <a:r>
-              <a:rPr sz="1050" b="1">
+                <a:spcPct val="112000"/>
+              </a:lnSpc>
+            </a:pPr>
+            <a:r>
+              <a:rPr sz="950" b="1">
                 <a:solidFill>
                   <a:srgbClr val="0F172A"/>
                 </a:solidFill>
                 <a:latin typeface="Calibri"/>
               </a:rPr>
-              <a:t>average HVAC energy saving from Guideline 36 sequences, against a baseline of existing practice</a:t>
-            </a:r>
-          </a:p>
-        </p:txBody>
-      </p:sp>
-      <p:sp>
-        <p:nvSpPr>
-          <p:cNvPr id="10" name="TextBox 9"/>
-          <p:cNvSpPr txBox="1"/>
-          <p:nvPr/>
-        </p:nvSpPr>
-        <p:spPr>
-          <a:xfrm>
-            <a:off x="877824" y="3246119"/>
-            <a:ext cx="2176272" cy="502920"/>
+              <a:t>average HVAC saving from Guideline 36 sequences, against existing practice</a:t>
+            </a:r>
+          </a:p>
+        </p:txBody>
+      </p:sp>
+      <p:sp>
+        <p:nvSpPr>
+          <p:cNvPr id="14" name="TextBox 13"/>
+          <p:cNvSpPr txBox="1"/>
+          <p:nvPr/>
+        </p:nvSpPr>
+        <p:spPr>
+          <a:xfrm>
+            <a:off x="822960" y="3401568"/>
+            <a:ext cx="2221992" cy="274320"/>
           </a:xfrm>
           <a:prstGeom prst="rect">
             <a:avLst/>
@@ -5240,31 +5396,114 @@
           <a:p>
             <a:pPr algn="l">
               <a:lnSpc>
-                <a:spcPct val="115000"/>
-              </a:lnSpc>
-            </a:pPr>
-            <a:r>
-              <a:rPr sz="800" b="0">
+                <a:spcPct val="112000"/>
+              </a:lnSpc>
+            </a:pPr>
+            <a:r>
+              <a:rPr sz="750" b="0">
                 <a:solidFill>
                   <a:srgbClr val="64748B"/>
                 </a:solidFill>
                 <a:latin typeface="Calibri"/>
               </a:rPr>
-              <a:t>Berkeley Lab, multi-zone VAV simulated in Spawn of EnergyPlus, medium office. J. Building Performance Simulation, 2022</a:t>
-            </a:r>
-          </a:p>
-        </p:txBody>
-      </p:sp>
-      <p:sp>
-        <p:nvSpPr>
-          <p:cNvPr id="11" name="Rounded Rectangle 10"/>
+              <a:t>Berkeley Lab, Spawn of EnergyPlus, medium office, 2022</a:t>
+            </a:r>
+          </a:p>
+        </p:txBody>
+      </p:sp>
+      <p:sp>
+        <p:nvSpPr>
+          <p:cNvPr id="15" name="Rectangle 14"/>
           <p:cNvSpPr/>
           <p:nvPr/>
         </p:nvSpPr>
         <p:spPr>
           <a:xfrm>
-            <a:off x="3401568" y="1874519"/>
-            <a:ext cx="2587752" cy="1920240"/>
+            <a:off x="822960" y="3666744"/>
+            <a:ext cx="18288" cy="347472"/>
+          </a:xfrm>
+          <a:prstGeom prst="rect">
+            <a:avLst/>
+          </a:prstGeom>
+          <a:solidFill>
+            <a:srgbClr val="E2E8F0"/>
+          </a:solidFill>
+          <a:ln>
+            <a:noFill/>
+          </a:ln>
+          <a:effectLst/>
+        </p:spPr>
+        <p:style>
+          <a:lnRef idx="1">
+            <a:schemeClr val="accent1"/>
+          </a:lnRef>
+          <a:fillRef idx="3">
+            <a:schemeClr val="accent1"/>
+          </a:fillRef>
+          <a:effectRef idx="2">
+            <a:schemeClr val="accent1"/>
+          </a:effectRef>
+          <a:fontRef idx="minor">
+            <a:schemeClr val="lt1"/>
+          </a:fontRef>
+        </p:style>
+        <p:txBody>
+          <a:bodyPr rtlCol="0" anchor="ctr"/>
+          <a:lstStyle/>
+          <a:p>
+            <a:pPr algn="ctr"/>
+          </a:p>
+        </p:txBody>
+      </p:sp>
+      <p:sp>
+        <p:nvSpPr>
+          <p:cNvPr id="16" name="TextBox 15"/>
+          <p:cNvSpPr txBox="1"/>
+          <p:nvPr/>
+        </p:nvSpPr>
+        <p:spPr>
+          <a:xfrm>
+            <a:off x="896112" y="3648456"/>
+            <a:ext cx="2148840" cy="384048"/>
+          </a:xfrm>
+          <a:prstGeom prst="rect">
+            <a:avLst/>
+          </a:prstGeom>
+          <a:noFill/>
+        </p:spPr>
+        <p:txBody>
+          <a:bodyPr wrap="square" anchor="t" lIns="25400" rIns="25400" tIns="25400" bIns="25400">
+            <a:spAutoFit/>
+          </a:bodyPr>
+          <a:lstStyle/>
+          <a:p>
+            <a:pPr algn="l">
+              <a:lnSpc>
+                <a:spcPct val="112000"/>
+              </a:lnSpc>
+            </a:pPr>
+            <a:r>
+              <a:rPr sz="750" b="0">
+                <a:solidFill>
+                  <a:srgbClr val="475569"/>
+                </a:solidFill>
+                <a:latin typeface="Calibri"/>
+              </a:rPr>
+              <a:t>Mostly static-pressure reset, zone minimum airflow and scheduling. Only the economizer and SAT logic land on the chart.</a:t>
+            </a:r>
+          </a:p>
+        </p:txBody>
+      </p:sp>
+      <p:sp>
+        <p:nvSpPr>
+          <p:cNvPr id="17" name="Rounded Rectangle 16"/>
+          <p:cNvSpPr/>
+          <p:nvPr/>
+        </p:nvSpPr>
+        <p:spPr>
+          <a:xfrm>
+            <a:off x="3438144" y="2340864"/>
+            <a:ext cx="2551176" cy="1783080"/>
           </a:xfrm>
           <a:prstGeom prst="roundRect">
             <a:avLst/>
@@ -5303,20 +5542,20 @@
       </p:sp>
       <p:sp>
         <p:nvSpPr>
-          <p:cNvPr id="12" name="Rectangle 11"/>
+          <p:cNvPr id="18" name="Rectangle 17"/>
           <p:cNvSpPr/>
           <p:nvPr/>
         </p:nvSpPr>
         <p:spPr>
           <a:xfrm>
-            <a:off x="3401568" y="1874519"/>
-            <a:ext cx="2587752" cy="91440"/>
+            <a:off x="3438144" y="2340864"/>
+            <a:ext cx="2551176" cy="82296"/>
           </a:xfrm>
           <a:prstGeom prst="rect">
             <a:avLst/>
           </a:prstGeom>
           <a:solidFill>
-            <a:srgbClr val="047857"/>
+            <a:srgbClr val="7C3AED"/>
           </a:solidFill>
           <a:ln>
             <a:noFill/>
@@ -5347,14 +5586,14 @@
       </p:sp>
       <p:sp>
         <p:nvSpPr>
-          <p:cNvPr id="13" name="TextBox 12"/>
-          <p:cNvSpPr txBox="1"/>
-          <p:nvPr/>
-        </p:nvSpPr>
-        <p:spPr>
-          <a:xfrm>
-            <a:off x="3639312" y="2057399"/>
-            <a:ext cx="2221992" cy="502920"/>
+          <p:cNvPr id="19" name="TextBox 18"/>
+          <p:cNvSpPr txBox="1"/>
+          <p:nvPr/>
+        </p:nvSpPr>
+        <p:spPr>
+          <a:xfrm>
+            <a:off x="3621024" y="2505456"/>
+            <a:ext cx="731520" cy="292608"/>
           </a:xfrm>
           <a:prstGeom prst="rect">
             <a:avLst/>
@@ -5373,27 +5612,27 @@
               </a:lnSpc>
             </a:pPr>
             <a:r>
-              <a:rPr sz="3000" b="1">
-                <a:solidFill>
-                  <a:srgbClr val="047857"/>
-                </a:solidFill>
-                <a:latin typeface="Calibri"/>
-              </a:rPr>
-              <a:t>9%</a:t>
-            </a:r>
-          </a:p>
-        </p:txBody>
-      </p:sp>
-      <p:sp>
-        <p:nvSpPr>
-          <p:cNvPr id="14" name="TextBox 13"/>
-          <p:cNvSpPr txBox="1"/>
-          <p:nvPr/>
-        </p:nvSpPr>
-        <p:spPr>
-          <a:xfrm>
-            <a:off x="3639312" y="2606039"/>
-            <a:ext cx="2176272" cy="594360"/>
+              <a:rPr sz="1900" b="1">
+                <a:solidFill>
+                  <a:srgbClr val="7C3AED"/>
+                </a:solidFill>
+                <a:latin typeface="Calibri"/>
+              </a:rPr>
+              <a:t>41%</a:t>
+            </a:r>
+          </a:p>
+        </p:txBody>
+      </p:sp>
+      <p:sp>
+        <p:nvSpPr>
+          <p:cNvPr id="20" name="TextBox 19"/>
+          <p:cNvSpPr txBox="1"/>
+          <p:nvPr/>
+        </p:nvSpPr>
+        <p:spPr>
+          <a:xfrm>
+            <a:off x="3621024" y="2761488"/>
+            <a:ext cx="777240" cy="182880"/>
           </a:xfrm>
           <a:prstGeom prst="rect">
             <a:avLst/>
@@ -5408,31 +5647,226 @@
           <a:p>
             <a:pPr algn="l">
               <a:lnSpc>
-                <a:spcPct val="115000"/>
-              </a:lnSpc>
-            </a:pPr>
-            <a:r>
-              <a:rPr sz="1050" b="1">
+                <a:spcPct val="106000"/>
+              </a:lnSpc>
+            </a:pPr>
+            <a:r>
+              <a:rPr sz="750" b="1">
+                <a:solidFill>
+                  <a:srgbClr val="64748B"/>
+                </a:solidFill>
+                <a:latin typeface="Calibri"/>
+              </a:rPr>
+              <a:t>HEATING</a:t>
+            </a:r>
+          </a:p>
+        </p:txBody>
+      </p:sp>
+      <p:sp>
+        <p:nvSpPr>
+          <p:cNvPr id="21" name="TextBox 20"/>
+          <p:cNvSpPr txBox="1"/>
+          <p:nvPr/>
+        </p:nvSpPr>
+        <p:spPr>
+          <a:xfrm>
+            <a:off x="4398264" y="2505456"/>
+            <a:ext cx="731520" cy="292608"/>
+          </a:xfrm>
+          <a:prstGeom prst="rect">
+            <a:avLst/>
+          </a:prstGeom>
+          <a:noFill/>
+        </p:spPr>
+        <p:txBody>
+          <a:bodyPr wrap="square" anchor="t" lIns="25400" rIns="25400" tIns="25400" bIns="25400">
+            <a:spAutoFit/>
+          </a:bodyPr>
+          <a:lstStyle/>
+          <a:p>
+            <a:pPr algn="l">
+              <a:lnSpc>
+                <a:spcPct val="106000"/>
+              </a:lnSpc>
+            </a:pPr>
+            <a:r>
+              <a:rPr sz="1900" b="1">
+                <a:solidFill>
+                  <a:srgbClr val="7C3AED"/>
+                </a:solidFill>
+                <a:latin typeface="Calibri"/>
+              </a:rPr>
+              <a:t>20%</a:t>
+            </a:r>
+          </a:p>
+        </p:txBody>
+      </p:sp>
+      <p:sp>
+        <p:nvSpPr>
+          <p:cNvPr id="22" name="TextBox 21"/>
+          <p:cNvSpPr txBox="1"/>
+          <p:nvPr/>
+        </p:nvSpPr>
+        <p:spPr>
+          <a:xfrm>
+            <a:off x="4398264" y="2761488"/>
+            <a:ext cx="777240" cy="182880"/>
+          </a:xfrm>
+          <a:prstGeom prst="rect">
+            <a:avLst/>
+          </a:prstGeom>
+          <a:noFill/>
+        </p:spPr>
+        <p:txBody>
+          <a:bodyPr wrap="square" anchor="t" lIns="25400" rIns="25400" tIns="25400" bIns="25400">
+            <a:spAutoFit/>
+          </a:bodyPr>
+          <a:lstStyle/>
+          <a:p>
+            <a:pPr algn="l">
+              <a:lnSpc>
+                <a:spcPct val="106000"/>
+              </a:lnSpc>
+            </a:pPr>
+            <a:r>
+              <a:rPr sz="750" b="1">
+                <a:solidFill>
+                  <a:srgbClr val="64748B"/>
+                </a:solidFill>
+                <a:latin typeface="Calibri"/>
+              </a:rPr>
+              <a:t>COOLING</a:t>
+            </a:r>
+          </a:p>
+        </p:txBody>
+      </p:sp>
+      <p:sp>
+        <p:nvSpPr>
+          <p:cNvPr id="23" name="TextBox 22"/>
+          <p:cNvSpPr txBox="1"/>
+          <p:nvPr/>
+        </p:nvSpPr>
+        <p:spPr>
+          <a:xfrm>
+            <a:off x="5175504" y="2505456"/>
+            <a:ext cx="731520" cy="292608"/>
+          </a:xfrm>
+          <a:prstGeom prst="rect">
+            <a:avLst/>
+          </a:prstGeom>
+          <a:noFill/>
+        </p:spPr>
+        <p:txBody>
+          <a:bodyPr wrap="square" anchor="t" lIns="25400" rIns="25400" tIns="25400" bIns="25400">
+            <a:spAutoFit/>
+          </a:bodyPr>
+          <a:lstStyle/>
+          <a:p>
+            <a:pPr algn="l">
+              <a:lnSpc>
+                <a:spcPct val="106000"/>
+              </a:lnSpc>
+            </a:pPr>
+            <a:r>
+              <a:rPr sz="1900" b="1">
+                <a:solidFill>
+                  <a:srgbClr val="7C3AED"/>
+                </a:solidFill>
+                <a:latin typeface="Calibri"/>
+              </a:rPr>
+              <a:t>18%</a:t>
+            </a:r>
+          </a:p>
+        </p:txBody>
+      </p:sp>
+      <p:sp>
+        <p:nvSpPr>
+          <p:cNvPr id="24" name="TextBox 23"/>
+          <p:cNvSpPr txBox="1"/>
+          <p:nvPr/>
+        </p:nvSpPr>
+        <p:spPr>
+          <a:xfrm>
+            <a:off x="5175504" y="2761488"/>
+            <a:ext cx="777240" cy="182880"/>
+          </a:xfrm>
+          <a:prstGeom prst="rect">
+            <a:avLst/>
+          </a:prstGeom>
+          <a:noFill/>
+        </p:spPr>
+        <p:txBody>
+          <a:bodyPr wrap="square" anchor="t" lIns="25400" rIns="25400" tIns="25400" bIns="25400">
+            <a:spAutoFit/>
+          </a:bodyPr>
+          <a:lstStyle/>
+          <a:p>
+            <a:pPr algn="l">
+              <a:lnSpc>
+                <a:spcPct val="106000"/>
+              </a:lnSpc>
+            </a:pPr>
+            <a:r>
+              <a:rPr sz="750" b="1">
+                <a:solidFill>
+                  <a:srgbClr val="64748B"/>
+                </a:solidFill>
+                <a:latin typeface="Calibri"/>
+              </a:rPr>
+              <a:t>SHOULDER</a:t>
+            </a:r>
+          </a:p>
+        </p:txBody>
+      </p:sp>
+      <p:sp>
+        <p:nvSpPr>
+          <p:cNvPr id="25" name="TextBox 24"/>
+          <p:cNvSpPr txBox="1"/>
+          <p:nvPr/>
+        </p:nvSpPr>
+        <p:spPr>
+          <a:xfrm>
+            <a:off x="3621024" y="2980944"/>
+            <a:ext cx="2221992" cy="457200"/>
+          </a:xfrm>
+          <a:prstGeom prst="rect">
+            <a:avLst/>
+          </a:prstGeom>
+          <a:noFill/>
+        </p:spPr>
+        <p:txBody>
+          <a:bodyPr wrap="square" anchor="t" lIns="25400" rIns="25400" tIns="25400" bIns="25400">
+            <a:spAutoFit/>
+          </a:bodyPr>
+          <a:lstStyle/>
+          <a:p>
+            <a:pPr algn="l">
+              <a:lnSpc>
+                <a:spcPct val="112000"/>
+              </a:lnSpc>
+            </a:pPr>
+            <a:r>
+              <a:rPr sz="950" b="1">
                 <a:solidFill>
                   <a:srgbClr val="0F172A"/>
                 </a:solidFill>
                 <a:latin typeface="Calibri"/>
               </a:rPr>
-              <a:t>median whole-building saving from fault detection, range 1–28%, two-year payback</a:t>
-            </a:r>
-          </a:p>
-        </p:txBody>
-      </p:sp>
-      <p:sp>
-        <p:nvSpPr>
-          <p:cNvPr id="15" name="TextBox 14"/>
-          <p:cNvSpPr txBox="1"/>
-          <p:nvPr/>
-        </p:nvSpPr>
-        <p:spPr>
-          <a:xfrm>
-            <a:off x="3639312" y="3246119"/>
-            <a:ext cx="2176272" cy="502920"/>
+              <a:t>seasonal saving from supervisory setpoint resets</a:t>
+            </a:r>
+          </a:p>
+        </p:txBody>
+      </p:sp>
+      <p:sp>
+        <p:nvSpPr>
+          <p:cNvPr id="26" name="TextBox 25"/>
+          <p:cNvSpPr txBox="1"/>
+          <p:nvPr/>
+        </p:nvSpPr>
+        <p:spPr>
+          <a:xfrm>
+            <a:off x="3621024" y="3401568"/>
+            <a:ext cx="2221992" cy="274320"/>
           </a:xfrm>
           <a:prstGeom prst="rect">
             <a:avLst/>
@@ -5447,31 +5881,114 @@
           <a:p>
             <a:pPr algn="l">
               <a:lnSpc>
-                <a:spcPct val="115000"/>
-              </a:lnSpc>
-            </a:pPr>
-            <a:r>
-              <a:rPr sz="800" b="0">
+                <a:spcPct val="112000"/>
+              </a:lnSpc>
+            </a:pPr>
+            <a:r>
+              <a:rPr sz="750" b="0">
                 <a:solidFill>
                   <a:srgbClr val="64748B"/>
                 </a:solidFill>
                 <a:latin typeface="Calibri"/>
               </a:rPr>
-              <a:t>Berkeley Lab Smart Energy Analytics Campaign — 6,500 buildings, over half a billion sq ft</a:t>
-            </a:r>
-          </a:p>
-        </p:txBody>
-      </p:sp>
-      <p:sp>
-        <p:nvSpPr>
-          <p:cNvPr id="16" name="Rounded Rectangle 15"/>
+              <a:t>PNNL large-office emulator, Chicago, 2024</a:t>
+            </a:r>
+          </a:p>
+        </p:txBody>
+      </p:sp>
+      <p:sp>
+        <p:nvSpPr>
+          <p:cNvPr id="27" name="Rectangle 26"/>
           <p:cNvSpPr/>
           <p:nvPr/>
         </p:nvSpPr>
         <p:spPr>
           <a:xfrm>
-            <a:off x="6163056" y="1874519"/>
-            <a:ext cx="2587752" cy="1920240"/>
+            <a:off x="3621024" y="3666744"/>
+            <a:ext cx="18288" cy="347472"/>
+          </a:xfrm>
+          <a:prstGeom prst="rect">
+            <a:avLst/>
+          </a:prstGeom>
+          <a:solidFill>
+            <a:srgbClr val="E2E8F0"/>
+          </a:solidFill>
+          <a:ln>
+            <a:noFill/>
+          </a:ln>
+          <a:effectLst/>
+        </p:spPr>
+        <p:style>
+          <a:lnRef idx="1">
+            <a:schemeClr val="accent1"/>
+          </a:lnRef>
+          <a:fillRef idx="3">
+            <a:schemeClr val="accent1"/>
+          </a:fillRef>
+          <a:effectRef idx="2">
+            <a:schemeClr val="accent1"/>
+          </a:effectRef>
+          <a:fontRef idx="minor">
+            <a:schemeClr val="lt1"/>
+          </a:fontRef>
+        </p:style>
+        <p:txBody>
+          <a:bodyPr rtlCol="0" anchor="ctr"/>
+          <a:lstStyle/>
+          <a:p>
+            <a:pPr algn="ctr"/>
+          </a:p>
+        </p:txBody>
+      </p:sp>
+      <p:sp>
+        <p:nvSpPr>
+          <p:cNvPr id="28" name="TextBox 27"/>
+          <p:cNvSpPr txBox="1"/>
+          <p:nvPr/>
+        </p:nvSpPr>
+        <p:spPr>
+          <a:xfrm>
+            <a:off x="3694176" y="3648456"/>
+            <a:ext cx="2148840" cy="384048"/>
+          </a:xfrm>
+          <a:prstGeom prst="rect">
+            <a:avLst/>
+          </a:prstGeom>
+          <a:noFill/>
+        </p:spPr>
+        <p:txBody>
+          <a:bodyPr wrap="square" anchor="t" lIns="25400" rIns="25400" tIns="25400" bIns="25400">
+            <a:spAutoFit/>
+          </a:bodyPr>
+          <a:lstStyle/>
+          <a:p>
+            <a:pPr algn="l">
+              <a:lnSpc>
+                <a:spcPct val="112000"/>
+              </a:lnSpc>
+            </a:pPr>
+            <a:r>
+              <a:rPr sz="750" b="0">
+                <a:solidFill>
+                  <a:srgbClr val="475569"/>
+                </a:solidFill>
+                <a:latin typeface="Calibri"/>
+              </a:rPr>
+              <a:t>Airside and plant-side combined — the chilled- and hot-water resets sit off the chart entirely.</a:t>
+            </a:r>
+          </a:p>
+        </p:txBody>
+      </p:sp>
+      <p:sp>
+        <p:nvSpPr>
+          <p:cNvPr id="29" name="Rounded Rectangle 28"/>
+          <p:cNvSpPr/>
+          <p:nvPr/>
+        </p:nvSpPr>
+        <p:spPr>
+          <a:xfrm>
+            <a:off x="6199632" y="2340864"/>
+            <a:ext cx="2551176" cy="1783080"/>
           </a:xfrm>
           <a:prstGeom prst="roundRect">
             <a:avLst/>
@@ -5510,20 +6027,20 @@
       </p:sp>
       <p:sp>
         <p:nvSpPr>
-          <p:cNvPr id="17" name="Rectangle 16"/>
+          <p:cNvPr id="30" name="Rectangle 29"/>
           <p:cNvSpPr/>
           <p:nvPr/>
         </p:nvSpPr>
         <p:spPr>
           <a:xfrm>
-            <a:off x="6163056" y="1874519"/>
-            <a:ext cx="2587752" cy="91440"/>
+            <a:off x="6199632" y="2340864"/>
+            <a:ext cx="2551176" cy="82296"/>
           </a:xfrm>
           <a:prstGeom prst="rect">
             <a:avLst/>
           </a:prstGeom>
           <a:solidFill>
-            <a:srgbClr val="B45309"/>
+            <a:srgbClr val="047857"/>
           </a:solidFill>
           <a:ln>
             <a:noFill/>
@@ -5554,14 +6071,14 @@
       </p:sp>
       <p:sp>
         <p:nvSpPr>
-          <p:cNvPr id="18" name="TextBox 17"/>
-          <p:cNvSpPr txBox="1"/>
-          <p:nvPr/>
-        </p:nvSpPr>
-        <p:spPr>
-          <a:xfrm>
-            <a:off x="6400800" y="2057399"/>
-            <a:ext cx="2221992" cy="502920"/>
+          <p:cNvPr id="31" name="TextBox 30"/>
+          <p:cNvSpPr txBox="1"/>
+          <p:nvPr/>
+        </p:nvSpPr>
+        <p:spPr>
+          <a:xfrm>
+            <a:off x="6382512" y="2505456"/>
+            <a:ext cx="2185416" cy="457200"/>
           </a:xfrm>
           <a:prstGeom prst="rect">
             <a:avLst/>
@@ -5580,27 +6097,27 @@
               </a:lnSpc>
             </a:pPr>
             <a:r>
-              <a:rPr sz="3000" b="1">
-                <a:solidFill>
-                  <a:srgbClr val="B45309"/>
-                </a:solidFill>
-                <a:latin typeface="Calibri"/>
-              </a:rPr>
-              <a:t>64%</a:t>
-            </a:r>
-          </a:p>
-        </p:txBody>
-      </p:sp>
-      <p:sp>
-        <p:nvSpPr>
-          <p:cNvPr id="19" name="TextBox 18"/>
-          <p:cNvSpPr txBox="1"/>
-          <p:nvPr/>
-        </p:nvSpPr>
-        <p:spPr>
-          <a:xfrm>
-            <a:off x="6400800" y="2606039"/>
-            <a:ext cx="2176272" cy="594360"/>
+              <a:rPr sz="2600" b="1">
+                <a:solidFill>
+                  <a:srgbClr val="047857"/>
+                </a:solidFill>
+                <a:latin typeface="Calibri"/>
+              </a:rPr>
+              <a:t>9%</a:t>
+            </a:r>
+          </a:p>
+        </p:txBody>
+      </p:sp>
+      <p:sp>
+        <p:nvSpPr>
+          <p:cNvPr id="32" name="TextBox 31"/>
+          <p:cNvSpPr txBox="1"/>
+          <p:nvPr/>
+        </p:nvSpPr>
+        <p:spPr>
+          <a:xfrm>
+            <a:off x="6382512" y="2980944"/>
+            <a:ext cx="2221992" cy="457200"/>
           </a:xfrm>
           <a:prstGeom prst="rect">
             <a:avLst/>
@@ -5615,31 +6132,31 @@
           <a:p>
             <a:pPr algn="l">
               <a:lnSpc>
-                <a:spcPct val="115000"/>
-              </a:lnSpc>
-            </a:pPr>
-            <a:r>
-              <a:rPr sz="1050" b="1">
+                <a:spcPct val="112000"/>
+              </a:lnSpc>
+            </a:pPr>
+            <a:r>
+              <a:rPr sz="950" b="1">
                 <a:solidFill>
                   <a:srgbClr val="0F172A"/>
                 </a:solidFill>
                 <a:latin typeface="Calibri"/>
               </a:rPr>
-              <a:t>of economizers found faulty in the field — free cooling paid for and never delivered</a:t>
-            </a:r>
-          </a:p>
-        </p:txBody>
-      </p:sp>
-      <p:sp>
-        <p:nvSpPr>
-          <p:cNvPr id="20" name="TextBox 19"/>
-          <p:cNvSpPr txBox="1"/>
-          <p:nvPr/>
-        </p:nvSpPr>
-        <p:spPr>
-          <a:xfrm>
-            <a:off x="6400800" y="3246119"/>
-            <a:ext cx="2176272" cy="502920"/>
+              <a:t>median whole-building saving from fault detection, range 1–28%</a:t>
+            </a:r>
+          </a:p>
+        </p:txBody>
+      </p:sp>
+      <p:sp>
+        <p:nvSpPr>
+          <p:cNvPr id="33" name="TextBox 32"/>
+          <p:cNvSpPr txBox="1"/>
+          <p:nvPr/>
+        </p:nvSpPr>
+        <p:spPr>
+          <a:xfrm>
+            <a:off x="6382512" y="3401568"/>
+            <a:ext cx="2221992" cy="274320"/>
           </a:xfrm>
           <a:prstGeom prst="rect">
             <a:avLst/>
@@ -5654,31 +6171,114 @@
           <a:p>
             <a:pPr algn="l">
               <a:lnSpc>
-                <a:spcPct val="115000"/>
-              </a:lnSpc>
-            </a:pPr>
-            <a:r>
-              <a:rPr sz="800" b="0">
+                <a:spcPct val="112000"/>
+              </a:lnSpc>
+            </a:pPr>
+            <a:r>
+              <a:rPr sz="750" b="0">
                 <a:solidFill>
                   <a:srgbClr val="64748B"/>
                 </a:solidFill>
                 <a:latin typeface="Calibri"/>
               </a:rPr>
-              <a:t>New Buildings Institute; a wider literature survey averages 58%, with 25–40% of rooftop units faulty at any moment</a:t>
-            </a:r>
-          </a:p>
-        </p:txBody>
-      </p:sp>
-      <p:sp>
-        <p:nvSpPr>
-          <p:cNvPr id="21" name="Rounded Rectangle 20"/>
+              <a:t>Berkeley Lab Smart Energy Analytics Campaign, 6,500 buildings</a:t>
+            </a:r>
+          </a:p>
+        </p:txBody>
+      </p:sp>
+      <p:sp>
+        <p:nvSpPr>
+          <p:cNvPr id="34" name="Rectangle 33"/>
           <p:cNvSpPr/>
           <p:nvPr/>
         </p:nvSpPr>
         <p:spPr>
           <a:xfrm>
-            <a:off x="8924544" y="1874519"/>
-            <a:ext cx="2587752" cy="1920240"/>
+            <a:off x="6382512" y="3666744"/>
+            <a:ext cx="18288" cy="347472"/>
+          </a:xfrm>
+          <a:prstGeom prst="rect">
+            <a:avLst/>
+          </a:prstGeom>
+          <a:solidFill>
+            <a:srgbClr val="E2E8F0"/>
+          </a:solidFill>
+          <a:ln>
+            <a:noFill/>
+          </a:ln>
+          <a:effectLst/>
+        </p:spPr>
+        <p:style>
+          <a:lnRef idx="1">
+            <a:schemeClr val="accent1"/>
+          </a:lnRef>
+          <a:fillRef idx="3">
+            <a:schemeClr val="accent1"/>
+          </a:fillRef>
+          <a:effectRef idx="2">
+            <a:schemeClr val="accent1"/>
+          </a:effectRef>
+          <a:fontRef idx="minor">
+            <a:schemeClr val="lt1"/>
+          </a:fontRef>
+        </p:style>
+        <p:txBody>
+          <a:bodyPr rtlCol="0" anchor="ctr"/>
+          <a:lstStyle/>
+          <a:p>
+            <a:pPr algn="ctr"/>
+          </a:p>
+        </p:txBody>
+      </p:sp>
+      <p:sp>
+        <p:nvSpPr>
+          <p:cNvPr id="35" name="TextBox 34"/>
+          <p:cNvSpPr txBox="1"/>
+          <p:nvPr/>
+        </p:nvSpPr>
+        <p:spPr>
+          <a:xfrm>
+            <a:off x="6455664" y="3648456"/>
+            <a:ext cx="2148840" cy="384048"/>
+          </a:xfrm>
+          <a:prstGeom prst="rect">
+            <a:avLst/>
+          </a:prstGeom>
+          <a:noFill/>
+        </p:spPr>
+        <p:txBody>
+          <a:bodyPr wrap="square" anchor="t" lIns="25400" rIns="25400" tIns="25400" bIns="25400">
+            <a:spAutoFit/>
+          </a:bodyPr>
+          <a:lstStyle/>
+          <a:p>
+            <a:pPr algn="l">
+              <a:lnSpc>
+                <a:spcPct val="112000"/>
+              </a:lnSpc>
+            </a:pPr>
+            <a:r>
+              <a:rPr sz="750" b="0">
+                <a:solidFill>
+                  <a:srgbClr val="475569"/>
+                </a:solidFill>
+                <a:latin typeface="Calibri"/>
+              </a:rPr>
+              <a:t>The standard AHU rule set (NIST APAR, 28 mass- and energy-balance tests) is this chart's geometry in algebra. Covers all FDD, so read it as an upper bound.</a:t>
+            </a:r>
+          </a:p>
+        </p:txBody>
+      </p:sp>
+      <p:sp>
+        <p:nvSpPr>
+          <p:cNvPr id="36" name="Rounded Rectangle 35"/>
+          <p:cNvSpPr/>
+          <p:nvPr/>
+        </p:nvSpPr>
+        <p:spPr>
+          <a:xfrm>
+            <a:off x="8997696" y="2340864"/>
+            <a:ext cx="2551176" cy="1783080"/>
           </a:xfrm>
           <a:prstGeom prst="roundRect">
             <a:avLst/>
@@ -5717,20 +6317,20 @@
       </p:sp>
       <p:sp>
         <p:nvSpPr>
-          <p:cNvPr id="22" name="Rectangle 21"/>
+          <p:cNvPr id="37" name="Rectangle 36"/>
           <p:cNvSpPr/>
           <p:nvPr/>
         </p:nvSpPr>
         <p:spPr>
           <a:xfrm>
-            <a:off x="8924544" y="1874519"/>
-            <a:ext cx="2587752" cy="91440"/>
+            <a:off x="8997696" y="2340864"/>
+            <a:ext cx="2551176" cy="82296"/>
           </a:xfrm>
           <a:prstGeom prst="rect">
             <a:avLst/>
           </a:prstGeom>
           <a:solidFill>
-            <a:srgbClr val="7C3AED"/>
+            <a:srgbClr val="B45309"/>
           </a:solidFill>
           <a:ln>
             <a:noFill/>
@@ -5761,14 +6361,14 @@
       </p:sp>
       <p:sp>
         <p:nvSpPr>
-          <p:cNvPr id="23" name="TextBox 22"/>
-          <p:cNvSpPr txBox="1"/>
-          <p:nvPr/>
-        </p:nvSpPr>
-        <p:spPr>
-          <a:xfrm>
-            <a:off x="9162288" y="2057399"/>
-            <a:ext cx="2221992" cy="502920"/>
+          <p:cNvPr id="38" name="TextBox 37"/>
+          <p:cNvSpPr txBox="1"/>
+          <p:nvPr/>
+        </p:nvSpPr>
+        <p:spPr>
+          <a:xfrm>
+            <a:off x="9180576" y="2505456"/>
+            <a:ext cx="2185416" cy="457200"/>
           </a:xfrm>
           <a:prstGeom prst="rect">
             <a:avLst/>
@@ -5787,27 +6387,27 @@
               </a:lnSpc>
             </a:pPr>
             <a:r>
-              <a:rPr sz="3000" b="1">
-                <a:solidFill>
-                  <a:srgbClr val="7C3AED"/>
-                </a:solidFill>
-                <a:latin typeface="Calibri"/>
-              </a:rPr>
-              <a:t>20–41%</a:t>
-            </a:r>
-          </a:p>
-        </p:txBody>
-      </p:sp>
-      <p:sp>
-        <p:nvSpPr>
-          <p:cNvPr id="24" name="TextBox 23"/>
-          <p:cNvSpPr txBox="1"/>
-          <p:nvPr/>
-        </p:nvSpPr>
-        <p:spPr>
-          <a:xfrm>
-            <a:off x="9162288" y="2606039"/>
-            <a:ext cx="2176272" cy="594360"/>
+              <a:rPr sz="2600" b="1">
+                <a:solidFill>
+                  <a:srgbClr val="B45309"/>
+                </a:solidFill>
+                <a:latin typeface="Calibri"/>
+              </a:rPr>
+              <a:t>64%</a:t>
+            </a:r>
+          </a:p>
+        </p:txBody>
+      </p:sp>
+      <p:sp>
+        <p:nvSpPr>
+          <p:cNvPr id="39" name="TextBox 38"/>
+          <p:cNvSpPr txBox="1"/>
+          <p:nvPr/>
+        </p:nvSpPr>
+        <p:spPr>
+          <a:xfrm>
+            <a:off x="9180576" y="2980944"/>
+            <a:ext cx="2221992" cy="457200"/>
           </a:xfrm>
           <a:prstGeom prst="rect">
             <a:avLst/>
@@ -5822,31 +6422,31 @@
           <a:p>
             <a:pPr algn="l">
               <a:lnSpc>
-                <a:spcPct val="115000"/>
-              </a:lnSpc>
-            </a:pPr>
-            <a:r>
-              <a:rPr sz="1050" b="1">
+                <a:spcPct val="112000"/>
+              </a:lnSpc>
+            </a:pPr>
+            <a:r>
+              <a:rPr sz="950" b="1">
                 <a:solidFill>
                   <a:srgbClr val="0F172A"/>
                 </a:solidFill>
                 <a:latin typeface="Calibri"/>
               </a:rPr>
-              <a:t>seasonal saving from supervisory setpoint resets: 20% cooling, 18% shoulder, 41% heating</a:t>
-            </a:r>
-          </a:p>
-        </p:txBody>
-      </p:sp>
-      <p:sp>
-        <p:nvSpPr>
-          <p:cNvPr id="25" name="TextBox 24"/>
-          <p:cNvSpPr txBox="1"/>
-          <p:nvPr/>
-        </p:nvSpPr>
-        <p:spPr>
-          <a:xfrm>
-            <a:off x="9162288" y="3246119"/>
-            <a:ext cx="2176272" cy="502920"/>
+              <a:t>of economizers found faulty in the field</a:t>
+            </a:r>
+          </a:p>
+        </p:txBody>
+      </p:sp>
+      <p:sp>
+        <p:nvSpPr>
+          <p:cNvPr id="40" name="TextBox 39"/>
+          <p:cNvSpPr txBox="1"/>
+          <p:nvPr/>
+        </p:nvSpPr>
+        <p:spPr>
+          <a:xfrm>
+            <a:off x="9180576" y="3401568"/>
+            <a:ext cx="2221992" cy="274320"/>
           </a:xfrm>
           <a:prstGeom prst="rect">
             <a:avLst/>
@@ -5861,31 +6461,197 @@
           <a:p>
             <a:pPr algn="l">
               <a:lnSpc>
-                <a:spcPct val="115000"/>
-              </a:lnSpc>
-            </a:pPr>
-            <a:r>
-              <a:rPr sz="800" b="0">
+                <a:spcPct val="112000"/>
+              </a:lnSpc>
+            </a:pPr>
+            <a:r>
+              <a:rPr sz="750" b="0">
                 <a:solidFill>
                   <a:srgbClr val="64748B"/>
                 </a:solidFill>
                 <a:latin typeface="Calibri"/>
               </a:rPr>
-              <a:t>PNNL, large-office emulator, Chicago, 2024 — airside and plant-side resets combined</a:t>
-            </a:r>
-          </a:p>
-        </p:txBody>
-      </p:sp>
-      <p:sp>
-        <p:nvSpPr>
-          <p:cNvPr id="26" name="Rounded Rectangle 25"/>
+              <a:t>New Buildings Institute; wider surveys average 58%</a:t>
+            </a:r>
+          </a:p>
+        </p:txBody>
+      </p:sp>
+      <p:sp>
+        <p:nvSpPr>
+          <p:cNvPr id="41" name="Rectangle 40"/>
           <p:cNvSpPr/>
           <p:nvPr/>
         </p:nvSpPr>
         <p:spPr>
           <a:xfrm>
-            <a:off x="640080" y="4041648"/>
-            <a:ext cx="5349240" cy="1783080"/>
+            <a:off x="9180576" y="3666744"/>
+            <a:ext cx="18288" cy="347472"/>
+          </a:xfrm>
+          <a:prstGeom prst="rect">
+            <a:avLst/>
+          </a:prstGeom>
+          <a:solidFill>
+            <a:srgbClr val="E2E8F0"/>
+          </a:solidFill>
+          <a:ln>
+            <a:noFill/>
+          </a:ln>
+          <a:effectLst/>
+        </p:spPr>
+        <p:style>
+          <a:lnRef idx="1">
+            <a:schemeClr val="accent1"/>
+          </a:lnRef>
+          <a:fillRef idx="3">
+            <a:schemeClr val="accent1"/>
+          </a:fillRef>
+          <a:effectRef idx="2">
+            <a:schemeClr val="accent1"/>
+          </a:effectRef>
+          <a:fontRef idx="minor">
+            <a:schemeClr val="lt1"/>
+          </a:fontRef>
+        </p:style>
+        <p:txBody>
+          <a:bodyPr rtlCol="0" anchor="ctr"/>
+          <a:lstStyle/>
+          <a:p>
+            <a:pPr algn="ctr"/>
+          </a:p>
+        </p:txBody>
+      </p:sp>
+      <p:sp>
+        <p:nvSpPr>
+          <p:cNvPr id="42" name="TextBox 41"/>
+          <p:cNvSpPr txBox="1"/>
+          <p:nvPr/>
+        </p:nvSpPr>
+        <p:spPr>
+          <a:xfrm>
+            <a:off x="9253728" y="3648456"/>
+            <a:ext cx="2148840" cy="384048"/>
+          </a:xfrm>
+          <a:prstGeom prst="rect">
+            <a:avLst/>
+          </a:prstGeom>
+          <a:noFill/>
+        </p:spPr>
+        <p:txBody>
+          <a:bodyPr wrap="square" anchor="t" lIns="25400" rIns="25400" tIns="25400" bIns="25400">
+            <a:spAutoFit/>
+          </a:bodyPr>
+          <a:lstStyle/>
+          <a:p>
+            <a:pPr algn="l">
+              <a:lnSpc>
+                <a:spcPct val="112000"/>
+              </a:lnSpc>
+            </a:pPr>
+            <a:r>
+              <a:rPr sz="750" b="0">
+                <a:solidFill>
+                  <a:srgbClr val="475569"/>
+                </a:solidFill>
+                <a:latin typeface="Calibri"/>
+              </a:rPr>
+              <a:t>Opportunity size, not a return: how often the free-cooling asset is already broken. The chart is how you notice.</a:t>
+            </a:r>
+          </a:p>
+        </p:txBody>
+      </p:sp>
+      <p:sp>
+        <p:nvSpPr>
+          <p:cNvPr id="43" name="Rounded Rectangle 42"/>
+          <p:cNvSpPr/>
+          <p:nvPr/>
+        </p:nvSpPr>
+        <p:spPr>
+          <a:xfrm>
+            <a:off x="10652759" y="2505456"/>
+            <a:ext cx="731520" cy="182880"/>
+          </a:xfrm>
+          <a:prstGeom prst="roundRect">
+            <a:avLst/>
+          </a:prstGeom>
+          <a:solidFill>
+            <a:srgbClr val="FEF3C7"/>
+          </a:solidFill>
+          <a:ln>
+            <a:noFill/>
+          </a:ln>
+          <a:effectLst/>
+        </p:spPr>
+        <p:style>
+          <a:lnRef idx="1">
+            <a:schemeClr val="accent1"/>
+          </a:lnRef>
+          <a:fillRef idx="3">
+            <a:schemeClr val="accent1"/>
+          </a:fillRef>
+          <a:effectRef idx="2">
+            <a:schemeClr val="accent1"/>
+          </a:effectRef>
+          <a:fontRef idx="minor">
+            <a:schemeClr val="lt1"/>
+          </a:fontRef>
+        </p:style>
+        <p:txBody>
+          <a:bodyPr rtlCol="0" anchor="ctr"/>
+          <a:lstStyle/>
+          <a:p>
+            <a:pPr algn="ctr"/>
+          </a:p>
+        </p:txBody>
+      </p:sp>
+      <p:sp>
+        <p:nvSpPr>
+          <p:cNvPr id="44" name="TextBox 43"/>
+          <p:cNvSpPr txBox="1"/>
+          <p:nvPr/>
+        </p:nvSpPr>
+        <p:spPr>
+          <a:xfrm>
+            <a:off x="10652759" y="2519172"/>
+            <a:ext cx="731520" cy="164592"/>
+          </a:xfrm>
+          <a:prstGeom prst="rect">
+            <a:avLst/>
+          </a:prstGeom>
+          <a:noFill/>
+        </p:spPr>
+        <p:txBody>
+          <a:bodyPr wrap="square" anchor="t" lIns="25400" rIns="25400" tIns="25400" bIns="25400">
+            <a:spAutoFit/>
+          </a:bodyPr>
+          <a:lstStyle/>
+          <a:p>
+            <a:pPr algn="ctr">
+              <a:lnSpc>
+                <a:spcPct val="106000"/>
+              </a:lnSpc>
+            </a:pPr>
+            <a:r>
+              <a:rPr sz="650" b="1">
+                <a:solidFill>
+                  <a:srgbClr val="92400E"/>
+                </a:solidFill>
+                <a:latin typeface="Calibri"/>
+              </a:rPr>
+              <a:t>NOT A SAVING</a:t>
+            </a:r>
+          </a:p>
+        </p:txBody>
+      </p:sp>
+      <p:sp>
+        <p:nvSpPr>
+          <p:cNvPr id="45" name="Rounded Rectangle 44"/>
+          <p:cNvSpPr/>
+          <p:nvPr/>
+        </p:nvSpPr>
+        <p:spPr>
+          <a:xfrm>
+            <a:off x="640080" y="4206240"/>
+            <a:ext cx="5349240" cy="1719072"/>
           </a:xfrm>
           <a:prstGeom prst="roundRect">
             <a:avLst/>
@@ -5924,14 +6690,14 @@
       </p:sp>
       <p:sp>
         <p:nvSpPr>
-          <p:cNvPr id="27" name="TextBox 26"/>
-          <p:cNvSpPr txBox="1"/>
-          <p:nvPr/>
-        </p:nvSpPr>
-        <p:spPr>
-          <a:xfrm>
-            <a:off x="896112" y="4169663"/>
-            <a:ext cx="4846320" cy="292608"/>
+          <p:cNvPr id="46" name="TextBox 45"/>
+          <p:cNvSpPr txBox="1"/>
+          <p:nvPr/>
+        </p:nvSpPr>
+        <p:spPr>
+          <a:xfrm>
+            <a:off x="896112" y="4315968"/>
+            <a:ext cx="4846320" cy="274320"/>
           </a:xfrm>
           <a:prstGeom prst="rect">
             <a:avLst/>
@@ -5950,7 +6716,7 @@
               </a:lnSpc>
             </a:pPr>
             <a:r>
-              <a:rPr sz="1400" b="1">
+              <a:rPr sz="1300" b="1">
                 <a:solidFill>
                   <a:srgbClr val="047857"/>
                 </a:solidFill>
@@ -5963,14 +6729,14 @@
       </p:sp>
       <p:sp>
         <p:nvSpPr>
-          <p:cNvPr id="28" name="TextBox 27"/>
-          <p:cNvSpPr txBox="1"/>
-          <p:nvPr/>
-        </p:nvSpPr>
-        <p:spPr>
-          <a:xfrm>
-            <a:off x="896112" y="4526280"/>
-            <a:ext cx="4892040" cy="1234440"/>
+          <p:cNvPr id="47" name="TextBox 46"/>
+          <p:cNvSpPr txBox="1"/>
+          <p:nvPr/>
+        </p:nvSpPr>
+        <p:spPr>
+          <a:xfrm>
+            <a:off x="896112" y="4636008"/>
+            <a:ext cx="4892040" cy="1170432"/>
           </a:xfrm>
           <a:prstGeom prst="rect">
             <a:avLst/>
@@ -5985,11 +6751,11 @@
           <a:p>
             <a:pPr algn="l">
               <a:lnSpc>
-                <a:spcPct val="120000"/>
-              </a:lnSpc>
-            </a:pPr>
-            <a:r>
-              <a:rPr sz="1050" b="0">
+                <a:spcPct val="118000"/>
+              </a:lnSpc>
+            </a:pPr>
+            <a:r>
+              <a:rPr sz="950" b="0">
                 <a:solidFill>
                   <a:srgbClr val="475569"/>
                 </a:solidFill>
@@ -6001,11 +6767,11 @@
           <a:p>
             <a:pPr algn="l">
               <a:lnSpc>
-                <a:spcPct val="120000"/>
-              </a:lnSpc>
-            </a:pPr>
-            <a:r>
-              <a:rPr sz="1050" b="0">
+                <a:spcPct val="118000"/>
+              </a:lnSpc>
+            </a:pPr>
+            <a:r>
+              <a:rPr sz="950" b="0">
                 <a:solidFill>
                   <a:srgbClr val="475569"/>
                 </a:solidFill>
@@ -6017,11 +6783,11 @@
           <a:p>
             <a:pPr algn="l">
               <a:lnSpc>
-                <a:spcPct val="120000"/>
-              </a:lnSpc>
-            </a:pPr>
-            <a:r>
-              <a:rPr sz="1050" b="0">
+                <a:spcPct val="118000"/>
+              </a:lnSpc>
+            </a:pPr>
+            <a:r>
+              <a:rPr sz="950" b="0">
                 <a:solidFill>
                   <a:srgbClr val="475569"/>
                 </a:solidFill>
@@ -6033,11 +6799,11 @@
           <a:p>
             <a:pPr algn="l">
               <a:lnSpc>
-                <a:spcPct val="120000"/>
-              </a:lnSpc>
-            </a:pPr>
-            <a:r>
-              <a:rPr sz="1050" b="0">
+                <a:spcPct val="118000"/>
+              </a:lnSpc>
+            </a:pPr>
+            <a:r>
+              <a:rPr sz="950" b="0">
                 <a:solidFill>
                   <a:srgbClr val="475569"/>
                 </a:solidFill>
@@ -6050,14 +6816,14 @@
       </p:sp>
       <p:sp>
         <p:nvSpPr>
-          <p:cNvPr id="29" name="Rounded Rectangle 28"/>
+          <p:cNvPr id="48" name="Rounded Rectangle 47"/>
           <p:cNvSpPr/>
           <p:nvPr/>
         </p:nvSpPr>
         <p:spPr>
           <a:xfrm>
-            <a:off x="6199632" y="4041648"/>
-            <a:ext cx="5349240" cy="1783080"/>
+            <a:off x="6199632" y="4206240"/>
+            <a:ext cx="5349240" cy="1719072"/>
           </a:xfrm>
           <a:prstGeom prst="roundRect">
             <a:avLst/>
@@ -6096,14 +6862,14 @@
       </p:sp>
       <p:sp>
         <p:nvSpPr>
-          <p:cNvPr id="30" name="TextBox 29"/>
-          <p:cNvSpPr txBox="1"/>
-          <p:nvPr/>
-        </p:nvSpPr>
-        <p:spPr>
-          <a:xfrm>
-            <a:off x="6455664" y="4169663"/>
-            <a:ext cx="4846320" cy="292608"/>
+          <p:cNvPr id="49" name="TextBox 48"/>
+          <p:cNvSpPr txBox="1"/>
+          <p:nvPr/>
+        </p:nvSpPr>
+        <p:spPr>
+          <a:xfrm>
+            <a:off x="6455664" y="4315968"/>
+            <a:ext cx="4846320" cy="274320"/>
           </a:xfrm>
           <a:prstGeom prst="rect">
             <a:avLst/>
@@ -6122,7 +6888,7 @@
               </a:lnSpc>
             </a:pPr>
             <a:r>
-              <a:rPr sz="1400" b="1">
+              <a:rPr sz="1300" b="1">
                 <a:solidFill>
                   <a:srgbClr val="B45309"/>
                 </a:solidFill>
@@ -6135,14 +6901,14 @@
       </p:sp>
       <p:sp>
         <p:nvSpPr>
-          <p:cNvPr id="31" name="TextBox 30"/>
-          <p:cNvSpPr txBox="1"/>
-          <p:nvPr/>
-        </p:nvSpPr>
-        <p:spPr>
-          <a:xfrm>
-            <a:off x="6455664" y="4526280"/>
-            <a:ext cx="4892040" cy="1234440"/>
+          <p:cNvPr id="50" name="TextBox 49"/>
+          <p:cNvSpPr txBox="1"/>
+          <p:nvPr/>
+        </p:nvSpPr>
+        <p:spPr>
+          <a:xfrm>
+            <a:off x="6455664" y="4636008"/>
+            <a:ext cx="4892040" cy="1170432"/>
           </a:xfrm>
           <a:prstGeom prst="rect">
             <a:avLst/>
@@ -6157,104 +6923,104 @@
           <a:p>
             <a:pPr algn="l">
               <a:lnSpc>
+                <a:spcPct val="118000"/>
+              </a:lnSpc>
+            </a:pPr>
+            <a:r>
+              <a:rPr sz="950" b="0">
+                <a:solidFill>
+                  <a:srgbClr val="475569"/>
+                </a:solidFill>
+                <a:latin typeface="Calibri"/>
+              </a:rPr>
+              <a:t>•  Measure-level results from simulation and field studies — not a guarantee for any one building.</a:t>
+            </a:r>
+          </a:p>
+          <a:p>
+            <a:pPr algn="l">
+              <a:lnSpc>
+                <a:spcPct val="118000"/>
+              </a:lnSpc>
+            </a:pPr>
+            <a:r>
+              <a:rPr sz="950" b="0">
+                <a:solidFill>
+                  <a:srgbClr val="475569"/>
+                </a:solidFill>
+                <a:latin typeface="Calibri"/>
+              </a:rPr>
+              <a:t>•  They overlap and are not additive; the left pair and the right pair count much of the same energy twice.</a:t>
+            </a:r>
+          </a:p>
+          <a:p>
+            <a:pPr algn="l">
+              <a:lnSpc>
+                <a:spcPct val="118000"/>
+              </a:lnSpc>
+            </a:pPr>
+            <a:r>
+              <a:rPr sz="950" b="0">
+                <a:solidFill>
+                  <a:srgbClr val="475569"/>
+                </a:solidFill>
+                <a:latin typeface="Calibri"/>
+              </a:rPr>
+              <a:t>•  The largest savings come from the worst starting points.</a:t>
+            </a:r>
+          </a:p>
+          <a:p>
+            <a:pPr algn="l">
+              <a:lnSpc>
+                <a:spcPct val="118000"/>
+              </a:lnSpc>
+            </a:pPr>
+            <a:r>
+              <a:rPr sz="950" b="0">
+                <a:solidFill>
+                  <a:srgbClr val="475569"/>
+                </a:solidFill>
+                <a:latin typeface="Calibri"/>
+              </a:rPr>
+              <a:t>•  Enthalpy switching is NOT automatically better — Taylor &amp; Cheng (2010) found fixed dry-bulb often wins once humidity sensors drift, hence 90.1-2013's accuracy limits.</a:t>
+            </a:r>
+          </a:p>
+        </p:txBody>
+      </p:sp>
+      <p:sp>
+        <p:nvSpPr>
+          <p:cNvPr id="51" name="TextBox 50"/>
+          <p:cNvSpPr txBox="1"/>
+          <p:nvPr/>
+        </p:nvSpPr>
+        <p:spPr>
+          <a:xfrm>
+            <a:off x="640080" y="6016752"/>
+            <a:ext cx="10908792" cy="548640"/>
+          </a:xfrm>
+          <a:prstGeom prst="rect">
+            <a:avLst/>
+          </a:prstGeom>
+          <a:noFill/>
+        </p:spPr>
+        <p:txBody>
+          <a:bodyPr wrap="square" anchor="t" lIns="25400" rIns="25400" tIns="25400" bIns="25400">
+            <a:spAutoFit/>
+          </a:bodyPr>
+          <a:lstStyle/>
+          <a:p>
+            <a:pPr algn="ctr">
+              <a:lnSpc>
                 <a:spcPct val="120000"/>
               </a:lnSpc>
             </a:pPr>
             <a:r>
-              <a:rPr sz="1050" b="0">
-                <a:solidFill>
-                  <a:srgbClr val="475569"/>
-                </a:solidFill>
-                <a:latin typeface="Calibri"/>
-              </a:rPr>
-              <a:t>•  They are measure-level results from simulation and field studies — not a guarantee for any one building.</a:t>
-            </a:r>
-          </a:p>
-          <a:p>
-            <a:pPr algn="l">
-              <a:lnSpc>
-                <a:spcPct val="120000"/>
-              </a:lnSpc>
-            </a:pPr>
-            <a:r>
-              <a:rPr sz="1050" b="0">
-                <a:solidFill>
-                  <a:srgbClr val="475569"/>
-                </a:solidFill>
-                <a:latin typeface="Calibri"/>
-              </a:rPr>
-              <a:t>•  They overlap heavily. Do not add them together.</a:t>
-            </a:r>
-          </a:p>
-          <a:p>
-            <a:pPr algn="l">
-              <a:lnSpc>
-                <a:spcPct val="120000"/>
-              </a:lnSpc>
-            </a:pPr>
-            <a:r>
-              <a:rPr sz="1050" b="0">
-                <a:solidFill>
-                  <a:srgbClr val="475569"/>
-                </a:solidFill>
-                <a:latin typeface="Calibri"/>
-              </a:rPr>
-              <a:t>•  The largest savings come from the worst starting points; a well-commissioned building has less to gain.</a:t>
-            </a:r>
-          </a:p>
-          <a:p>
-            <a:pPr algn="l">
-              <a:lnSpc>
-                <a:spcPct val="120000"/>
-              </a:lnSpc>
-            </a:pPr>
-            <a:r>
-              <a:rPr sz="1050" b="0">
-                <a:solidFill>
-                  <a:srgbClr val="475569"/>
-                </a:solidFill>
-                <a:latin typeface="Calibri"/>
-              </a:rPr>
-              <a:t>•  Enthalpy switching is NOT automatically better. Taylor &amp; Cheng (ASHRAE Journal, 2010) found fixed dry-bulb often wins once humidity-sensor drift is counted — hence the 90.1-2013 sensor limits.</a:t>
-            </a:r>
-          </a:p>
-        </p:txBody>
-      </p:sp>
-      <p:sp>
-        <p:nvSpPr>
-          <p:cNvPr id="32" name="TextBox 31"/>
-          <p:cNvSpPr txBox="1"/>
-          <p:nvPr/>
-        </p:nvSpPr>
-        <p:spPr>
-          <a:xfrm>
-            <a:off x="640080" y="6035040"/>
-            <a:ext cx="10908792" cy="548640"/>
-          </a:xfrm>
-          <a:prstGeom prst="rect">
-            <a:avLst/>
-          </a:prstGeom>
-          <a:noFill/>
-        </p:spPr>
-        <p:txBody>
-          <a:bodyPr wrap="square" anchor="t" lIns="25400" rIns="25400" tIns="25400" bIns="25400">
-            <a:spAutoFit/>
-          </a:bodyPr>
-          <a:lstStyle/>
-          <a:p>
-            <a:pPr algn="ctr">
-              <a:lnSpc>
-                <a:spcPct val="120000"/>
-              </a:lnSpc>
-            </a:pPr>
-            <a:r>
               <a:rPr sz="1300" b="1">
                 <a:solidFill>
                   <a:srgbClr val="1D4ED8"/>
                 </a:solidFill>
                 <a:latin typeface="Calibri"/>
               </a:rPr>
-              <a:t>The chart itself saves nothing. It makes the opportunity visible and the fault obvious — the saving comes from acting on what it shows.</a:t>
+              <a:t>The chart itself saves nothing. It makes the opportunity visible and the fault obvious — the saving is booked by the sequence that acts on it.</a:t>
             </a:r>
           </a:p>
         </p:txBody>

</xml_diff>